<commit_message>
Add judge-validation workflow slide to the deck
New slide 'Who validates the validator?' summarizes the human-in-the-loop
benchmark: run -> capture -> human labels ground truth -> score judge vs human
-> fold back, with the false-positive focus and synthetic-labels caveat.
</commit_message>
<xml_diff>
--- a/Workload Specific Evaluations/Multiagent Shared Context Evaluation/Evaluating-Agent-Functions.pptx
+++ b/Workload Specific Evaluations/Multiagent Shared Context Evaluation/Evaluating-Agent-Functions.pptx
@@ -12,6 +12,8 @@
     <p:sldId id="260" r:id="rId11"/>
     <p:sldId id="261" r:id="rId12"/>
     <p:sldId id="262" r:id="rId13"/>
+    <p:sldId id="263" r:id="rId14"/>
+    <p:sldId id="264" r:id="rId15"/>
   </p:sldIdLst>
   <p:sldSz cx="12191695" cy="6858000" type="screen4x3"/>
   <p:notesSz cx="6858000" cy="9144000"/>
@@ -5525,7 +5527,7 @@
                 </a:solidFill>
                 <a:latin typeface="Calibri"/>
               </a:rPr>
-              <a:t>CAUTION 1</a:t>
+              <a:t>THE DATASET</a:t>
             </a:r>
           </a:p>
           <a:p>
@@ -5544,30 +5546,74 @@
                 </a:solidFill>
                 <a:latin typeface="Calibri"/>
               </a:rPr>
-              <a:t>Failures hide in the seams between personas</a:t>
-            </a:r>
-          </a:p>
-        </p:txBody>
-      </p:sp>
-      <p:sp>
-        <p:nvSpPr>
-          <p:cNvPr id="6" name="Rounded Rectangle 5"/>
+              <a:t>What you evaluate against: grounded research briefs</a:t>
+            </a:r>
+          </a:p>
+        </p:txBody>
+      </p:sp>
+      <p:sp>
+        <p:nvSpPr>
+          <p:cNvPr id="6" name="TextBox 5"/>
+          <p:cNvSpPr txBox="1"/>
+          <p:nvPr/>
+        </p:nvSpPr>
+        <p:spPr>
+          <a:xfrm>
+            <a:off x="548640" y="1298448"/>
+            <a:ext cx="11064240" cy="566928"/>
+          </a:xfrm>
+          <a:prstGeom prst="rect">
+            <a:avLst/>
+          </a:prstGeom>
+          <a:noFill/>
+        </p:spPr>
+        <p:txBody>
+          <a:bodyPr wrap="square" anchor="t">
+            <a:spAutoFit/>
+          </a:bodyPr>
+          <a:lstStyle/>
+          <a:p>
+            <a:pPr algn="l">
+              <a:lnSpc>
+                <a:spcPct val="103000"/>
+              </a:lnSpc>
+              <a:spcAft>
+                <a:spcPts val="600"/>
+              </a:spcAft>
+            </a:pPr>
+            <a:r>
+              <a:rPr sz="1400" b="0">
+                <a:solidFill>
+                  <a:srgbClr val="5B6470"/>
+                </a:solidFill>
+                <a:latin typeface="Calibri"/>
+              </a:rPr>
+              <a:t>You cannot judge “good analysis” without a reference. Step 1 of the loop is a dataset: briefs + the verifiable facts each one states.</a:t>
+            </a:r>
+          </a:p>
+        </p:txBody>
+      </p:sp>
+      <p:sp>
+        <p:nvSpPr>
+          <p:cNvPr id="7" name="Rounded Rectangle 6"/>
           <p:cNvSpPr/>
           <p:nvPr/>
         </p:nvSpPr>
         <p:spPr>
           <a:xfrm>
-            <a:off x="548640" y="1325880"/>
-            <a:ext cx="2011680" cy="384048"/>
+            <a:off x="960120" y="2011680"/>
+            <a:ext cx="2331720" cy="777240"/>
           </a:xfrm>
           <a:prstGeom prst="roundRect">
             <a:avLst/>
           </a:prstGeom>
           <a:solidFill>
-            <a:srgbClr val="C0392B"/>
-          </a:solidFill>
-          <a:ln>
-            <a:noFill/>
+            <a:srgbClr val="FFFFFF"/>
+          </a:solidFill>
+          <a:ln w="25400">
+            <a:solidFill>
+              <a:srgbClr val="6B4EC4"/>
+            </a:solidFill>
           </a:ln>
           <a:effectLst/>
         </p:spPr>
@@ -5598,27 +5644,71 @@
               </a:spcAft>
             </a:pPr>
             <a:r>
-              <a:rPr sz="1200" b="1">
-                <a:solidFill>
-                  <a:srgbClr val="FFFFFF"/>
-                </a:solidFill>
-                <a:latin typeface="Calibri"/>
-              </a:rPr>
-              <a:t>CAUTION 1</a:t>
-            </a:r>
-          </a:p>
-        </p:txBody>
-      </p:sp>
-      <p:sp>
-        <p:nvSpPr>
-          <p:cNvPr id="7" name="Rounded Rectangle 6"/>
+              <a:rPr sz="1300" b="1">
+                <a:solidFill>
+                  <a:srgbClr val="6B4EC4"/>
+                </a:solidFill>
+                <a:latin typeface="Calibri"/>
+              </a:rPr>
+              <a:t>Research brief</a:t>
+            </a:r>
+          </a:p>
+        </p:txBody>
+      </p:sp>
+      <p:sp>
+        <p:nvSpPr>
+          <p:cNvPr id="8" name="Right Arrow 7"/>
           <p:cNvSpPr/>
           <p:nvPr/>
         </p:nvSpPr>
         <p:spPr>
           <a:xfrm>
-            <a:off x="548640" y="1965960"/>
-            <a:ext cx="5486400" cy="1417320"/>
+            <a:off x="3292840" y="2267712"/>
+            <a:ext cx="500920" cy="274320"/>
+          </a:xfrm>
+          <a:prstGeom prst="rightArrow">
+            <a:avLst/>
+          </a:prstGeom>
+          <a:solidFill>
+            <a:srgbClr val="E08A1E"/>
+          </a:solidFill>
+          <a:ln>
+            <a:noFill/>
+          </a:ln>
+          <a:effectLst/>
+        </p:spPr>
+        <p:style>
+          <a:lnRef idx="1">
+            <a:schemeClr val="accent1"/>
+          </a:lnRef>
+          <a:fillRef idx="3">
+            <a:schemeClr val="accent1"/>
+          </a:fillRef>
+          <a:effectRef idx="2">
+            <a:schemeClr val="accent1"/>
+          </a:effectRef>
+          <a:fontRef idx="minor">
+            <a:schemeClr val="lt1"/>
+          </a:fontRef>
+        </p:style>
+        <p:txBody>
+          <a:bodyPr rtlCol="0" anchor="ctr"/>
+          <a:lstStyle/>
+          <a:p>
+            <a:pPr algn="ctr"/>
+          </a:p>
+        </p:txBody>
+      </p:sp>
+      <p:sp>
+        <p:nvSpPr>
+          <p:cNvPr id="9" name="Rounded Rectangle 8"/>
+          <p:cNvSpPr/>
+          <p:nvPr/>
+        </p:nvSpPr>
+        <p:spPr>
+          <a:xfrm>
+            <a:off x="3794760" y="2011680"/>
+            <a:ext cx="2331720" cy="777240"/>
           </a:xfrm>
           <a:prstGeom prst="roundRect">
             <a:avLst/>
@@ -5626,7 +5716,113 @@
           <a:solidFill>
             <a:srgbClr val="FFFFFF"/>
           </a:solidFill>
-          <a:ln w="22225">
+          <a:ln w="25400">
+            <a:solidFill>
+              <a:srgbClr val="2D6CDF"/>
+            </a:solidFill>
+          </a:ln>
+          <a:effectLst/>
+        </p:spPr>
+        <p:style>
+          <a:lnRef idx="1">
+            <a:schemeClr val="accent1"/>
+          </a:lnRef>
+          <a:fillRef idx="3">
+            <a:schemeClr val="accent1"/>
+          </a:fillRef>
+          <a:effectRef idx="2">
+            <a:schemeClr val="accent1"/>
+          </a:effectRef>
+          <a:fontRef idx="minor">
+            <a:schemeClr val="lt1"/>
+          </a:fontRef>
+        </p:style>
+        <p:txBody>
+          <a:bodyPr rtlCol="0" anchor="ctr" wrap="square"/>
+          <a:lstStyle/>
+          <a:p>
+            <a:pPr algn="ctr">
+              <a:lnSpc>
+                <a:spcPct val="103000"/>
+              </a:lnSpc>
+              <a:spcAft>
+                <a:spcPts val="0"/>
+              </a:spcAft>
+            </a:pPr>
+            <a:r>
+              <a:rPr sz="1300" b="1">
+                <a:solidFill>
+                  <a:srgbClr val="2D6CDF"/>
+                </a:solidFill>
+                <a:latin typeface="Calibri"/>
+              </a:rPr>
+              <a:t>market_trends</a:t>
+            </a:r>
+          </a:p>
+        </p:txBody>
+      </p:sp>
+      <p:sp>
+        <p:nvSpPr>
+          <p:cNvPr id="10" name="Right Arrow 9"/>
+          <p:cNvSpPr/>
+          <p:nvPr/>
+        </p:nvSpPr>
+        <p:spPr>
+          <a:xfrm>
+            <a:off x="6127480" y="2267712"/>
+            <a:ext cx="500920" cy="274320"/>
+          </a:xfrm>
+          <a:prstGeom prst="rightArrow">
+            <a:avLst/>
+          </a:prstGeom>
+          <a:solidFill>
+            <a:srgbClr val="E08A1E"/>
+          </a:solidFill>
+          <a:ln>
+            <a:noFill/>
+          </a:ln>
+          <a:effectLst/>
+        </p:spPr>
+        <p:style>
+          <a:lnRef idx="1">
+            <a:schemeClr val="accent1"/>
+          </a:lnRef>
+          <a:fillRef idx="3">
+            <a:schemeClr val="accent1"/>
+          </a:fillRef>
+          <a:effectRef idx="2">
+            <a:schemeClr val="accent1"/>
+          </a:effectRef>
+          <a:fontRef idx="minor">
+            <a:schemeClr val="lt1"/>
+          </a:fontRef>
+        </p:style>
+        <p:txBody>
+          <a:bodyPr rtlCol="0" anchor="ctr"/>
+          <a:lstStyle/>
+          <a:p>
+            <a:pPr algn="ctr"/>
+          </a:p>
+        </p:txBody>
+      </p:sp>
+      <p:sp>
+        <p:nvSpPr>
+          <p:cNvPr id="11" name="Rounded Rectangle 10"/>
+          <p:cNvSpPr/>
+          <p:nvPr/>
+        </p:nvSpPr>
+        <p:spPr>
+          <a:xfrm>
+            <a:off x="6629400" y="2011680"/>
+            <a:ext cx="2331720" cy="777240"/>
+          </a:xfrm>
+          <a:prstGeom prst="roundRect">
+            <a:avLst/>
+          </a:prstGeom>
+          <a:solidFill>
+            <a:srgbClr val="FFFFFF"/>
+          </a:solidFill>
+          <a:ln w="25400">
             <a:solidFill>
               <a:srgbClr val="129E8F"/>
             </a:solidFill>
@@ -5648,29 +5844,45 @@
           </a:fontRef>
         </p:style>
         <p:txBody>
-          <a:bodyPr rtlCol="0" anchor="ctr"/>
-          <a:lstStyle/>
-          <a:p>
-            <a:pPr algn="ctr"/>
-          </a:p>
-        </p:txBody>
-      </p:sp>
-      <p:sp>
-        <p:nvSpPr>
-          <p:cNvPr id="8" name="Rectangle 7"/>
+          <a:bodyPr rtlCol="0" anchor="ctr" wrap="square"/>
+          <a:lstStyle/>
+          <a:p>
+            <a:pPr algn="ctr">
+              <a:lnSpc>
+                <a:spcPct val="103000"/>
+              </a:lnSpc>
+              <a:spcAft>
+                <a:spcPts val="0"/>
+              </a:spcAft>
+            </a:pPr>
+            <a:r>
+              <a:rPr sz="1300" b="1">
+                <a:solidFill>
+                  <a:srgbClr val="129E8F"/>
+                </a:solidFill>
+                <a:latin typeface="Calibri"/>
+              </a:rPr>
+              <a:t>customer_insights</a:t>
+            </a:r>
+          </a:p>
+        </p:txBody>
+      </p:sp>
+      <p:sp>
+        <p:nvSpPr>
+          <p:cNvPr id="12" name="Right Arrow 11"/>
           <p:cNvSpPr/>
           <p:nvPr/>
         </p:nvSpPr>
         <p:spPr>
           <a:xfrm>
-            <a:off x="548640" y="1965960"/>
-            <a:ext cx="118872" cy="1417320"/>
-          </a:xfrm>
-          <a:prstGeom prst="rect">
-            <a:avLst/>
-          </a:prstGeom>
-          <a:solidFill>
-            <a:srgbClr val="129E8F"/>
+            <a:off x="8962120" y="2267712"/>
+            <a:ext cx="500920" cy="274320"/>
+          </a:xfrm>
+          <a:prstGeom prst="rightArrow">
+            <a:avLst/>
+          </a:prstGeom>
+          <a:solidFill>
+            <a:srgbClr val="E08A1E"/>
           </a:solidFill>
           <a:ln>
             <a:noFill/>
@@ -5701,75 +5913,14 @@
       </p:sp>
       <p:sp>
         <p:nvSpPr>
-          <p:cNvPr id="9" name="TextBox 8"/>
-          <p:cNvSpPr txBox="1"/>
-          <p:nvPr/>
-        </p:nvSpPr>
-        <p:spPr>
-          <a:xfrm>
-            <a:off x="841248" y="2112264"/>
-            <a:ext cx="4983480" cy="1143000"/>
-          </a:xfrm>
-          <a:prstGeom prst="rect">
-            <a:avLst/>
-          </a:prstGeom>
-          <a:noFill/>
-        </p:spPr>
-        <p:txBody>
-          <a:bodyPr wrap="square" anchor="t">
-            <a:spAutoFit/>
-          </a:bodyPr>
-          <a:lstStyle/>
-          <a:p>
-            <a:pPr algn="l">
-              <a:lnSpc>
-                <a:spcPct val="103000"/>
-              </a:lnSpc>
-              <a:spcAft>
-                <a:spcPts val="500"/>
-              </a:spcAft>
-            </a:pPr>
-            <a:r>
-              <a:rPr sz="1500" b="1">
-                <a:solidFill>
-                  <a:srgbClr val="129E8F"/>
-                </a:solidFill>
-                <a:latin typeface="Calibri"/>
-              </a:rPr>
-              <a:t>Engineer's view: Write Accuracy = 5/5</a:t>
-            </a:r>
-          </a:p>
-          <a:p>
-            <a:pPr algn="l">
-              <a:lnSpc>
-                <a:spcPct val="103000"/>
-              </a:lnSpc>
-              <a:spcAft>
-                <a:spcPts val="500"/>
-              </a:spcAft>
-            </a:pPr>
-            <a:r>
-              <a:rPr sz="1300" b="0">
-                <a:solidFill>
-                  <a:srgbClr val="1A1F2B"/>
-                </a:solidFill>
-                <a:latin typeface="Calibri"/>
-              </a:rPr>
-              <a:t>“The output is consistent with the input it was given.”  → looks healthy.</a:t>
-            </a:r>
-          </a:p>
-        </p:txBody>
-      </p:sp>
-      <p:sp>
-        <p:nvSpPr>
-          <p:cNvPr id="10" name="Rounded Rectangle 9"/>
+          <p:cNvPr id="13" name="Rounded Rectangle 12"/>
           <p:cNvSpPr/>
           <p:nvPr/>
         </p:nvSpPr>
         <p:spPr>
           <a:xfrm>
-            <a:off x="548640" y="3566160"/>
-            <a:ext cx="5486400" cy="1417320"/>
+            <a:off x="9464040" y="2011680"/>
+            <a:ext cx="2331720" cy="777240"/>
           </a:xfrm>
           <a:prstGeom prst="roundRect">
             <a:avLst/>
@@ -5777,9 +5928,9 @@
           <a:solidFill>
             <a:srgbClr val="FFFFFF"/>
           </a:solidFill>
-          <a:ln w="22225">
+          <a:ln w="25400">
             <a:solidFill>
-              <a:srgbClr val="C0392B"/>
+              <a:srgbClr val="0F2A4A"/>
             </a:solidFill>
           </a:ln>
           <a:effectLst/>
@@ -5799,32 +5950,50 @@
           </a:fontRef>
         </p:style>
         <p:txBody>
-          <a:bodyPr rtlCol="0" anchor="ctr"/>
-          <a:lstStyle/>
-          <a:p>
-            <a:pPr algn="ctr"/>
-          </a:p>
-        </p:txBody>
-      </p:sp>
-      <p:sp>
-        <p:nvSpPr>
-          <p:cNvPr id="11" name="Rectangle 10"/>
+          <a:bodyPr rtlCol="0" anchor="ctr" wrap="square"/>
+          <a:lstStyle/>
+          <a:p>
+            <a:pPr algn="ctr">
+              <a:lnSpc>
+                <a:spcPct val="103000"/>
+              </a:lnSpc>
+              <a:spcAft>
+                <a:spcPts val="0"/>
+              </a:spcAft>
+            </a:pPr>
+            <a:r>
+              <a:rPr sz="1300" b="1">
+                <a:solidFill>
+                  <a:srgbClr val="0F2A4A"/>
+                </a:solidFill>
+                <a:latin typeface="Calibri"/>
+              </a:rPr>
+              <a:t>strategy_synth</a:t>
+            </a:r>
+          </a:p>
+        </p:txBody>
+      </p:sp>
+      <p:sp>
+        <p:nvSpPr>
+          <p:cNvPr id="14" name="Rounded Rectangle 13"/>
           <p:cNvSpPr/>
           <p:nvPr/>
         </p:nvSpPr>
         <p:spPr>
           <a:xfrm>
-            <a:off x="548640" y="3566160"/>
-            <a:ext cx="118872" cy="1417320"/>
-          </a:xfrm>
-          <a:prstGeom prst="rect">
-            <a:avLst/>
-          </a:prstGeom>
-          <a:solidFill>
-            <a:srgbClr val="C0392B"/>
-          </a:solidFill>
-          <a:ln>
-            <a:noFill/>
+            <a:off x="548640" y="3154680"/>
+            <a:ext cx="5486400" cy="2514600"/>
+          </a:xfrm>
+          <a:prstGeom prst="roundRect">
+            <a:avLst/>
+          </a:prstGeom>
+          <a:solidFill>
+            <a:srgbClr val="1B222E"/>
+          </a:solidFill>
+          <a:ln w="12700">
+            <a:solidFill>
+              <a:srgbClr val="D6DEEA"/>
+            </a:solidFill>
           </a:ln>
           <a:effectLst/>
         </p:spPr>
@@ -5843,84 +6012,172 @@
           </a:fontRef>
         </p:style>
         <p:txBody>
-          <a:bodyPr rtlCol="0" anchor="ctr"/>
-          <a:lstStyle/>
-          <a:p>
-            <a:pPr algn="ctr"/>
-          </a:p>
-        </p:txBody>
-      </p:sp>
-      <p:sp>
-        <p:nvSpPr>
-          <p:cNvPr id="12" name="TextBox 11"/>
-          <p:cNvSpPr txBox="1"/>
-          <p:nvPr/>
-        </p:nvSpPr>
-        <p:spPr>
-          <a:xfrm>
-            <a:off x="841248" y="3712464"/>
-            <a:ext cx="4983480" cy="1143000"/>
-          </a:xfrm>
-          <a:prstGeom prst="rect">
-            <a:avLst/>
-          </a:prstGeom>
-          <a:noFill/>
-        </p:spPr>
-        <p:txBody>
-          <a:bodyPr wrap="square" anchor="t">
-            <a:spAutoFit/>
-          </a:bodyPr>
-          <a:lstStyle/>
-          <a:p>
-            <a:pPr algn="l">
-              <a:lnSpc>
-                <a:spcPct val="103000"/>
-              </a:lnSpc>
-              <a:spcAft>
-                <a:spcPts val="500"/>
-              </a:spcAft>
-            </a:pPr>
-            <a:r>
-              <a:rPr sz="1500" b="1">
-                <a:solidFill>
-                  <a:srgbClr val="C0392B"/>
-                </a:solidFill>
-                <a:latin typeface="Calibri"/>
-              </a:rPr>
-              <a:t>PM's view: Groundedness = 2/5</a:t>
-            </a:r>
-          </a:p>
-          <a:p>
-            <a:pPr algn="l">
-              <a:lnSpc>
-                <a:spcPct val="103000"/>
-              </a:lnSpc>
-              <a:spcAft>
-                <a:spcPts val="500"/>
-              </a:spcAft>
-            </a:pPr>
-            <a:r>
-              <a:rPr sz="1300" b="0">
-                <a:solidFill>
-                  <a:srgbClr val="1A1F2B"/>
-                </a:solidFill>
-                <a:latin typeface="Calibri"/>
-              </a:rPr>
-              <a:t>“The output does not match reality — the input premise was wrong.”  → broken.</a:t>
-            </a:r>
-          </a:p>
-        </p:txBody>
-      </p:sp>
-      <p:sp>
-        <p:nvSpPr>
-          <p:cNvPr id="13" name="Rounded Rectangle 12"/>
+          <a:bodyPr rtlCol="0" anchor="t" wrap="square" lIns="256032" tIns="182880"/>
+          <a:lstStyle/>
+          <a:p>
+            <a:pPr algn="l">
+              <a:lnSpc>
+                <a:spcPct val="103000"/>
+              </a:lnSpc>
+              <a:spcAft>
+                <a:spcPts val="400"/>
+              </a:spcAft>
+            </a:pPr>
+            <a:r>
+              <a:rPr sz="1300" b="1">
+                <a:solidFill>
+                  <a:srgbClr val="7FD0C8"/>
+                </a:solidFill>
+                <a:latin typeface="Calibri"/>
+              </a:rPr>
+              <a:t>datasets/research_briefs.jsonl</a:t>
+            </a:r>
+          </a:p>
+          <a:p>
+            <a:pPr algn="l">
+              <a:lnSpc>
+                <a:spcPct val="103000"/>
+              </a:lnSpc>
+              <a:spcAft>
+                <a:spcPts val="400"/>
+              </a:spcAft>
+            </a:pPr>
+            <a:r>
+              <a:rPr sz="1200" b="0">
+                <a:solidFill>
+                  <a:srgbClr val="FFFFFF"/>
+                </a:solidFill>
+                <a:latin typeface="Calibri"/>
+              </a:rPr>
+              <a:t>{</a:t>
+            </a:r>
+          </a:p>
+          <a:p>
+            <a:pPr algn="l">
+              <a:lnSpc>
+                <a:spcPct val="103000"/>
+              </a:lnSpc>
+              <a:spcAft>
+                <a:spcPts val="400"/>
+              </a:spcAft>
+            </a:pPr>
+            <a:r>
+              <a:rPr sz="1200" b="0">
+                <a:solidFill>
+                  <a:srgbClr val="D6DEEA"/>
+                </a:solidFill>
+                <a:latin typeface="Calibri"/>
+              </a:rPr>
+              <a:t>  "id": "brief-01-fastcasual",</a:t>
+            </a:r>
+          </a:p>
+          <a:p>
+            <a:pPr algn="l">
+              <a:lnSpc>
+                <a:spcPct val="103000"/>
+              </a:lnSpc>
+              <a:spcAft>
+                <a:spcPts val="400"/>
+              </a:spcAft>
+            </a:pPr>
+            <a:r>
+              <a:rPr sz="1200" b="0">
+                <a:solidFill>
+                  <a:srgbClr val="D6DEEA"/>
+                </a:solidFill>
+                <a:latin typeface="Calibri"/>
+              </a:rPr>
+              <a:t>  "turns": [ "Analyse the fast-casual market…" ],</a:t>
+            </a:r>
+          </a:p>
+          <a:p>
+            <a:pPr algn="l">
+              <a:lnSpc>
+                <a:spcPct val="103000"/>
+              </a:lnSpc>
+              <a:spcAft>
+                <a:spcPts val="400"/>
+              </a:spcAft>
+            </a:pPr>
+            <a:r>
+              <a:rPr sz="1200" b="0">
+                <a:solidFill>
+                  <a:srgbClr val="9CD1FF"/>
+                </a:solidFill>
+                <a:latin typeface="Calibri"/>
+              </a:rPr>
+              <a:t>  "facts": { market_size: $60B, growth: 8%,</a:t>
+            </a:r>
+          </a:p>
+          <a:p>
+            <a:pPr algn="l">
+              <a:lnSpc>
+                <a:spcPct val="103000"/>
+              </a:lnSpc>
+              <a:spcAft>
+                <a:spcPts val="400"/>
+              </a:spcAft>
+            </a:pPr>
+            <a:r>
+              <a:rPr sz="1200" b="0">
+                <a:solidFill>
+                  <a:srgbClr val="9CD1FF"/>
+                </a:solidFill>
+                <a:latin typeface="Calibri"/>
+              </a:rPr>
+              <a:t>            players: [Chipotle, Panera, Sweetgreen] },</a:t>
+            </a:r>
+          </a:p>
+          <a:p>
+            <a:pPr algn="l">
+              <a:lnSpc>
+                <a:spcPct val="103000"/>
+              </a:lnSpc>
+              <a:spcAft>
+                <a:spcPts val="400"/>
+              </a:spcAft>
+            </a:pPr>
+            <a:r>
+              <a:rPr sz="1200" b="0">
+                <a:solidFill>
+                  <a:srgbClr val="D6DEEA"/>
+                </a:solidFill>
+                <a:latin typeface="Calibri"/>
+              </a:rPr>
+              <a:t>  "premise_valid": true</a:t>
+            </a:r>
+          </a:p>
+          <a:p>
+            <a:pPr algn="l">
+              <a:lnSpc>
+                <a:spcPct val="103000"/>
+              </a:lnSpc>
+              <a:spcAft>
+                <a:spcPts val="400"/>
+              </a:spcAft>
+            </a:pPr>
+            <a:r>
+              <a:rPr sz="1200" b="0">
+                <a:solidFill>
+                  <a:srgbClr val="FFFFFF"/>
+                </a:solidFill>
+                <a:latin typeface="Calibri"/>
+              </a:rPr>
+              <a:t>}</a:t>
+            </a:r>
+          </a:p>
+        </p:txBody>
+      </p:sp>
+      <p:sp>
+        <p:nvSpPr>
+          <p:cNvPr id="15" name="Rounded Rectangle 14"/>
           <p:cNvSpPr/>
           <p:nvPr/>
         </p:nvSpPr>
         <p:spPr>
           <a:xfrm>
-            <a:off x="6309360" y="1965960"/>
-            <a:ext cx="5349240" cy="3931920"/>
+            <a:off x="6309360" y="3154680"/>
+            <a:ext cx="5349240" cy="2514600"/>
           </a:xfrm>
           <a:prstGeom prst="roundRect">
             <a:avLst/>
@@ -5928,9 +6185,9 @@
           <a:solidFill>
             <a:srgbClr val="F2F5FA"/>
           </a:solidFill>
-          <a:ln w="25400">
+          <a:ln w="19050">
             <a:solidFill>
-              <a:srgbClr val="C0392B"/>
+              <a:srgbClr val="6B4EC4"/>
             </a:solidFill>
           </a:ln>
           <a:effectLst/>
@@ -5950,124 +6207,144 @@
           </a:fontRef>
         </p:style>
         <p:txBody>
-          <a:bodyPr rtlCol="0" anchor="t" wrap="square" lIns="292608" rIns="256032" tIns="256032"/>
-          <a:lstStyle/>
-          <a:p>
-            <a:pPr algn="l">
-              <a:lnSpc>
-                <a:spcPct val="103000"/>
-              </a:lnSpc>
-              <a:spcAft>
-                <a:spcPts val="900"/>
-              </a:spcAft>
-            </a:pPr>
-            <a:r>
-              <a:rPr sz="1600" b="1">
+          <a:bodyPr rtlCol="0" anchor="t" wrap="square" lIns="274320" tIns="182880"/>
+          <a:lstStyle/>
+          <a:p>
+            <a:pPr algn="l">
+              <a:lnSpc>
+                <a:spcPct val="103000"/>
+              </a:lnSpc>
+              <a:spcAft>
+                <a:spcPts val="600"/>
+              </a:spcAft>
+            </a:pPr>
+            <a:r>
+              <a:rPr sz="1400" b="1">
+                <a:solidFill>
+                  <a:srgbClr val="6B4EC4"/>
+                </a:solidFill>
+                <a:latin typeface="Calibri"/>
+              </a:rPr>
+              <a:t>facts  →  source_facts  →  Groundedness judge</a:t>
+            </a:r>
+          </a:p>
+          <a:p>
+            <a:pPr algn="l">
+              <a:lnSpc>
+                <a:spcPct val="103000"/>
+              </a:lnSpc>
+              <a:spcAft>
+                <a:spcPts val="600"/>
+              </a:spcAft>
+            </a:pPr>
+            <a:r>
+              <a:rPr sz="1300" b="0">
                 <a:solidFill>
                   <a:srgbClr val="1A1F2B"/>
                 </a:solidFill>
                 <a:latin typeface="Calibri"/>
               </a:rPr>
-              <a:t>Same agent. Same turn. Two personas, opposite verdicts.</a:t>
-            </a:r>
-          </a:p>
-          <a:p>
-            <a:pPr algn="l">
-              <a:lnSpc>
-                <a:spcPct val="103000"/>
-              </a:lnSpc>
-              <a:spcAft>
-                <a:spcPts val="900"/>
-              </a:spcAft>
-            </a:pPr>
-            <a:r>
-              <a:rPr sz="1400" b="0">
+              <a:t>The stated facts become the ground-truth reference. The judge checks whether each agent’s output stays faithful to them — not just internally consistent.</a:t>
+            </a:r>
+          </a:p>
+          <a:p>
+            <a:pPr algn="l">
+              <a:lnSpc>
+                <a:spcPct val="103000"/>
+              </a:lnSpc>
+              <a:spcAft>
+                <a:spcPts val="600"/>
+              </a:spcAft>
+            </a:pPr>
+            <a:r>
+              <a:rPr sz="500" b="0">
                 <a:solidFill>
                   <a:srgbClr val="5B6470"/>
                 </a:solidFill>
                 <a:latin typeface="Calibri"/>
               </a:rPr>
-              <a:t>If each persona reads only their own column, nobody owns the seam — and the seam is exactly where the failure lives.</a:t>
-            </a:r>
-          </a:p>
-          <a:p>
-            <a:pPr algn="l">
-              <a:lnSpc>
-                <a:spcPct val="103000"/>
-              </a:lnSpc>
-              <a:spcAft>
-                <a:spcPts val="900"/>
-              </a:spcAft>
-            </a:pPr>
-            <a:r>
-              <a:rPr sz="600" b="0">
+              <a:t/>
+            </a:r>
+          </a:p>
+          <a:p>
+            <a:pPr algn="l">
+              <a:lnSpc>
+                <a:spcPct val="103000"/>
+              </a:lnSpc>
+              <a:spcAft>
+                <a:spcPts val="600"/>
+              </a:spcAft>
+            </a:pPr>
+            <a:r>
+              <a:rPr sz="1250" b="1">
+                <a:solidFill>
+                  <a:srgbClr val="0F2A4A"/>
+                </a:solidFill>
+                <a:latin typeface="Calibri"/>
+              </a:rPr>
+              <a:t>Option A (now):</a:t>
+            </a:r>
+            <a:r>
+              <a:rPr sz="1250" b="0">
+                <a:solidFill>
+                  <a:srgbClr val="1A1F2B"/>
+                </a:solidFill>
+                <a:latin typeface="Calibri"/>
+              </a:rPr>
+              <a:t> briefs + verifiable facts, no gold answers.</a:t>
+            </a:r>
+          </a:p>
+          <a:p>
+            <a:pPr algn="l">
+              <a:lnSpc>
+                <a:spcPct val="103000"/>
+              </a:lnSpc>
+              <a:spcAft>
+                <a:spcPts val="600"/>
+              </a:spcAft>
+            </a:pPr>
+            <a:r>
+              <a:rPr sz="1250" b="1">
                 <a:solidFill>
                   <a:srgbClr val="5B6470"/>
                 </a:solidFill>
                 <a:latin typeface="Calibri"/>
               </a:rPr>
-              <a:t/>
-            </a:r>
-          </a:p>
-          <a:p>
-            <a:pPr algn="l">
-              <a:lnSpc>
-                <a:spcPct val="103000"/>
-              </a:lnSpc>
-              <a:spcAft>
-                <a:spcPts val="900"/>
-              </a:spcAft>
-            </a:pPr>
-            <a:r>
-              <a:rPr sz="1500" b="1">
-                <a:solidFill>
-                  <a:srgbClr val="C0392B"/>
-                </a:solidFill>
-                <a:latin typeface="Calibri"/>
-              </a:rPr>
-              <a:t>Personas are lenses, not owners.</a:t>
-            </a:r>
-          </a:p>
-          <a:p>
-            <a:pPr algn="l">
-              <a:lnSpc>
-                <a:spcPct val="103000"/>
-              </a:lnSpc>
-              <a:spcAft>
-                <a:spcPts val="900"/>
-              </a:spcAft>
-            </a:pPr>
-            <a:r>
-              <a:rPr sz="1350" b="0">
-                <a:solidFill>
-                  <a:srgbClr val="1A1F2B"/>
-                </a:solidFill>
-                <a:latin typeface="Calibri"/>
-              </a:rPr>
-              <a:t>Everyone gets a home dashboard, but quality gates require a cross-persona read. Partitioning improves triage; taken as strict ownership it worsens detection.</a:t>
-            </a:r>
-          </a:p>
-        </p:txBody>
-      </p:sp>
-      <p:sp>
-        <p:nvSpPr>
-          <p:cNvPr id="14" name="Rounded Rectangle 13"/>
+              <a:t>Option B (later):</a:t>
+            </a:r>
+            <a:r>
+              <a:rPr sz="1250" b="0">
+                <a:solidFill>
+                  <a:srgbClr val="5B6470"/>
+                </a:solidFill>
+                <a:latin typeface="Calibri"/>
+              </a:rPr>
+              <a:t> add per-stage “good answer” references.</a:t>
+            </a:r>
+          </a:p>
+        </p:txBody>
+      </p:sp>
+      <p:sp>
+        <p:nvSpPr>
+          <p:cNvPr id="16" name="Rounded Rectangle 15"/>
           <p:cNvSpPr/>
           <p:nvPr/>
         </p:nvSpPr>
         <p:spPr>
           <a:xfrm>
-            <a:off x="6601968" y="2148840"/>
-            <a:ext cx="3108960" cy="384048"/>
+            <a:off x="6309360" y="5806440"/>
+            <a:ext cx="5349240" cy="685800"/>
           </a:xfrm>
           <a:prstGeom prst="roundRect">
             <a:avLst/>
           </a:prstGeom>
           <a:solidFill>
-            <a:srgbClr val="C0392B"/>
-          </a:solidFill>
-          <a:ln>
-            <a:noFill/>
+            <a:srgbClr val="FDF3E2"/>
+          </a:solidFill>
+          <a:ln w="19050">
+            <a:solidFill>
+              <a:srgbClr val="E08A1E"/>
+            </a:solidFill>
           </a:ln>
           <a:effectLst/>
         </p:spPr>
@@ -6086,10 +6363,10 @@
           </a:fontRef>
         </p:style>
         <p:txBody>
-          <a:bodyPr rtlCol="0" anchor="ctr" wrap="square"/>
-          <a:lstStyle/>
-          <a:p>
-            <a:pPr algn="ctr">
+          <a:bodyPr rtlCol="0" anchor="ctr" wrap="square" lIns="219456"/>
+          <a:lstStyle/>
+          <a:p>
+            <a:pPr algn="l">
               <a:lnSpc>
                 <a:spcPct val="103000"/>
               </a:lnSpc>
@@ -6098,13 +6375,22 @@
               </a:spcAft>
             </a:pPr>
             <a:r>
-              <a:rPr sz="1200" b="1">
-                <a:solidFill>
-                  <a:srgbClr val="FFFFFF"/>
-                </a:solidFill>
-                <a:latin typeface="Calibri"/>
-              </a:rPr>
-              <a:t>THE TRAP</a:t>
+              <a:rPr sz="1250" b="1">
+                <a:solidFill>
+                  <a:srgbClr val="E08A1E"/>
+                </a:solidFill>
+                <a:latin typeface="Calibri"/>
+              </a:rPr>
+              <a:t>⚠ One brief has a flawed premise</a:t>
+            </a:r>
+            <a:r>
+              <a:rPr sz="1200" b="0">
+                <a:solidFill>
+                  <a:srgbClr val="1A1F2B"/>
+                </a:solidFill>
+                <a:latin typeface="Calibri"/>
+              </a:rPr>
+              <a:t> — a good analyst should flag it, not restate the fake numbers.</a:t>
             </a:r>
           </a:p>
         </p:txBody>
@@ -6296,7 +6582,7 @@
                 </a:solidFill>
                 <a:latin typeface="Calibri"/>
               </a:rPr>
-              <a:t>CAUTION 2</a:t>
+              <a:t>TRUST THE JUDGE</a:t>
             </a:r>
           </a:p>
           <a:p>
@@ -6315,30 +6601,74 @@
                 </a:solidFill>
                 <a:latin typeface="Calibri"/>
               </a:rPr>
-              <a:t>The same metric means different things</a:t>
-            </a:r>
-          </a:p>
-        </p:txBody>
-      </p:sp>
-      <p:sp>
-        <p:nvSpPr>
-          <p:cNvPr id="6" name="Rounded Rectangle 5"/>
+              <a:t>Who validates the validator? A human-in-the-loop benchmark</a:t>
+            </a:r>
+          </a:p>
+        </p:txBody>
+      </p:sp>
+      <p:sp>
+        <p:nvSpPr>
+          <p:cNvPr id="6" name="TextBox 5"/>
+          <p:cNvSpPr txBox="1"/>
+          <p:nvPr/>
+        </p:nvSpPr>
+        <p:spPr>
+          <a:xfrm>
+            <a:off x="548640" y="1298448"/>
+            <a:ext cx="11064240" cy="548640"/>
+          </a:xfrm>
+          <a:prstGeom prst="rect">
+            <a:avLst/>
+          </a:prstGeom>
+          <a:noFill/>
+        </p:spPr>
+        <p:txBody>
+          <a:bodyPr wrap="square" anchor="t">
+            <a:spAutoFit/>
+          </a:bodyPr>
+          <a:lstStyle/>
+          <a:p>
+            <a:pPr algn="l">
+              <a:lnSpc>
+                <a:spcPct val="103000"/>
+              </a:lnSpc>
+              <a:spcAft>
+                <a:spcPts val="600"/>
+              </a:spcAft>
+            </a:pPr>
+            <a:r>
+              <a:rPr sz="1400" b="0">
+                <a:solidFill>
+                  <a:srgbClr val="5B6470"/>
+                </a:solidFill>
+                <a:latin typeface="Calibri"/>
+              </a:rPr>
+              <a:t>An LLM grades the pipeline. But nothing grades the LLM — until a human labels ground truth and we measure how often the judge agrees.</a:t>
+            </a:r>
+          </a:p>
+        </p:txBody>
+      </p:sp>
+      <p:sp>
+        <p:nvSpPr>
+          <p:cNvPr id="7" name="Rounded Rectangle 6"/>
           <p:cNvSpPr/>
           <p:nvPr/>
         </p:nvSpPr>
         <p:spPr>
           <a:xfrm>
-            <a:off x="548640" y="1325880"/>
-            <a:ext cx="2011680" cy="384048"/>
+            <a:off x="502920" y="2148840"/>
+            <a:ext cx="2084831" cy="1737360"/>
           </a:xfrm>
           <a:prstGeom prst="roundRect">
             <a:avLst/>
           </a:prstGeom>
           <a:solidFill>
-            <a:srgbClr val="E08A1E"/>
-          </a:solidFill>
-          <a:ln>
-            <a:noFill/>
+            <a:srgbClr val="FFFFFF"/>
+          </a:solidFill>
+          <a:ln w="25400">
+            <a:solidFill>
+              <a:srgbClr val="2D6CDF"/>
+            </a:solidFill>
           </a:ln>
           <a:effectLst/>
         </p:spPr>
@@ -6357,50 +6687,32 @@
           </a:fontRef>
         </p:style>
         <p:txBody>
-          <a:bodyPr rtlCol="0" anchor="ctr" wrap="square"/>
-          <a:lstStyle/>
-          <a:p>
-            <a:pPr algn="ctr">
-              <a:lnSpc>
-                <a:spcPct val="103000"/>
-              </a:lnSpc>
-              <a:spcAft>
-                <a:spcPts val="0"/>
-              </a:spcAft>
-            </a:pPr>
-            <a:r>
-              <a:rPr sz="1200" b="1">
-                <a:solidFill>
-                  <a:srgbClr val="FFFFFF"/>
-                </a:solidFill>
-                <a:latin typeface="Calibri"/>
-              </a:rPr>
-              <a:t>CAUTION 2</a:t>
-            </a:r>
-          </a:p>
-        </p:txBody>
-      </p:sp>
-      <p:sp>
-        <p:nvSpPr>
-          <p:cNvPr id="7" name="Rounded Rectangle 6"/>
+          <a:bodyPr rtlCol="0" anchor="ctr"/>
+          <a:lstStyle/>
+          <a:p>
+            <a:pPr algn="ctr"/>
+          </a:p>
+        </p:txBody>
+      </p:sp>
+      <p:sp>
+        <p:nvSpPr>
+          <p:cNvPr id="8" name="Rectangle 7"/>
           <p:cNvSpPr/>
           <p:nvPr/>
         </p:nvSpPr>
         <p:spPr>
           <a:xfrm>
-            <a:off x="548640" y="1965960"/>
-            <a:ext cx="5486400" cy="1417320"/>
-          </a:xfrm>
-          <a:prstGeom prst="roundRect">
-            <a:avLst/>
-          </a:prstGeom>
-          <a:solidFill>
-            <a:srgbClr val="FFFFFF"/>
-          </a:solidFill>
-          <a:ln w="22225">
-            <a:solidFill>
-              <a:srgbClr val="E08A1E"/>
-            </a:solidFill>
+            <a:off x="502920" y="2148840"/>
+            <a:ext cx="2084831" cy="420624"/>
+          </a:xfrm>
+          <a:prstGeom prst="rect">
+            <a:avLst/>
+          </a:prstGeom>
+          <a:solidFill>
+            <a:srgbClr val="2D6CDF"/>
+          </a:solidFill>
+          <a:ln>
+            <a:noFill/>
           </a:ln>
           <a:effectLst/>
         </p:spPr>
@@ -6419,25 +6731,83 @@
           </a:fontRef>
         </p:style>
         <p:txBody>
-          <a:bodyPr rtlCol="0" anchor="ctr"/>
-          <a:lstStyle/>
-          <a:p>
-            <a:pPr algn="ctr"/>
-          </a:p>
-        </p:txBody>
-      </p:sp>
-      <p:sp>
-        <p:nvSpPr>
-          <p:cNvPr id="8" name="Rectangle 7"/>
+          <a:bodyPr rtlCol="0" anchor="ctr" wrap="square"/>
+          <a:lstStyle/>
+          <a:p>
+            <a:pPr algn="ctr">
+              <a:lnSpc>
+                <a:spcPct val="103000"/>
+              </a:lnSpc>
+              <a:spcAft>
+                <a:spcPts val="0"/>
+              </a:spcAft>
+            </a:pPr>
+            <a:r>
+              <a:rPr sz="1250" b="1">
+                <a:solidFill>
+                  <a:srgbClr val="FFFFFF"/>
+                </a:solidFill>
+                <a:latin typeface="Calibri"/>
+              </a:rPr>
+              <a:t>1  RUN</a:t>
+            </a:r>
+          </a:p>
+        </p:txBody>
+      </p:sp>
+      <p:sp>
+        <p:nvSpPr>
+          <p:cNvPr id="9" name="TextBox 8"/>
+          <p:cNvSpPr txBox="1"/>
+          <p:nvPr/>
+        </p:nvSpPr>
+        <p:spPr>
+          <a:xfrm>
+            <a:off x="667512" y="2660904"/>
+            <a:ext cx="1755647" cy="1133856"/>
+          </a:xfrm>
+          <a:prstGeom prst="rect">
+            <a:avLst/>
+          </a:prstGeom>
+          <a:noFill/>
+        </p:spPr>
+        <p:txBody>
+          <a:bodyPr wrap="square" anchor="t">
+            <a:spAutoFit/>
+          </a:bodyPr>
+          <a:lstStyle/>
+          <a:p>
+            <a:pPr algn="l">
+              <a:lnSpc>
+                <a:spcPct val="103000"/>
+              </a:lnSpc>
+              <a:spcAft>
+                <a:spcPts val="0"/>
+              </a:spcAft>
+            </a:pPr>
+            <a:r>
+              <a:rPr sz="1200" b="0">
+                <a:solidFill>
+                  <a:srgbClr val="1A1F2B"/>
+                </a:solidFill>
+                <a:latin typeface="Calibri"/>
+              </a:rPr>
+              <a:t>Run every brief through the pipeline (live).</a:t>
+            </a:r>
+          </a:p>
+        </p:txBody>
+      </p:sp>
+      <p:sp>
+        <p:nvSpPr>
+          <p:cNvPr id="10" name="Right Arrow 9"/>
           <p:cNvSpPr/>
           <p:nvPr/>
         </p:nvSpPr>
         <p:spPr>
           <a:xfrm>
-            <a:off x="548640" y="1965960"/>
-            <a:ext cx="118872" cy="1417320"/>
-          </a:xfrm>
-          <a:prstGeom prst="rect">
+            <a:off x="2588251" y="2788920"/>
+            <a:ext cx="145304" cy="365760"/>
+          </a:xfrm>
+          <a:prstGeom prst="rightArrow">
             <a:avLst/>
           </a:prstGeom>
           <a:solidFill>
@@ -6472,75 +6842,14 @@
       </p:sp>
       <p:sp>
         <p:nvSpPr>
-          <p:cNvPr id="9" name="TextBox 8"/>
-          <p:cNvSpPr txBox="1"/>
-          <p:nvPr/>
-        </p:nvSpPr>
-        <p:spPr>
-          <a:xfrm>
-            <a:off x="841248" y="2112264"/>
-            <a:ext cx="4983480" cy="1143000"/>
-          </a:xfrm>
-          <a:prstGeom prst="rect">
-            <a:avLst/>
-          </a:prstGeom>
-          <a:noFill/>
-        </p:spPr>
-        <p:txBody>
-          <a:bodyPr wrap="square" anchor="t">
-            <a:spAutoFit/>
-          </a:bodyPr>
-          <a:lstStyle/>
-          <a:p>
-            <a:pPr algn="l">
-              <a:lnSpc>
-                <a:spcPct val="103000"/>
-              </a:lnSpc>
-              <a:spcAft>
-                <a:spcPts val="500"/>
-              </a:spcAft>
-            </a:pPr>
-            <a:r>
-              <a:rPr sz="1500" b="1">
-                <a:solidFill>
-                  <a:srgbClr val="E08A1E"/>
-                </a:solidFill>
-                <a:latin typeface="Calibri"/>
-              </a:rPr>
-              <a:t>Coordination Token %</a:t>
-            </a:r>
-          </a:p>
-          <a:p>
-            <a:pPr algn="l">
-              <a:lnSpc>
-                <a:spcPct val="103000"/>
-              </a:lnSpc>
-              <a:spcAft>
-                <a:spcPts val="500"/>
-              </a:spcAft>
-            </a:pPr>
-            <a:r>
-              <a:rPr sz="1300" b="0">
-                <a:solidFill>
-                  <a:srgbClr val="1A1F2B"/>
-                </a:solidFill>
-                <a:latin typeface="Calibri"/>
-              </a:rPr>
-              <a:t>SRE reads it as COST. Engineer reads it as context bloat / prompt quality.</a:t>
-            </a:r>
-          </a:p>
-        </p:txBody>
-      </p:sp>
-      <p:sp>
-        <p:nvSpPr>
-          <p:cNvPr id="10" name="Rounded Rectangle 9"/>
+          <p:cNvPr id="11" name="Rounded Rectangle 10"/>
           <p:cNvSpPr/>
           <p:nvPr/>
         </p:nvSpPr>
         <p:spPr>
           <a:xfrm>
-            <a:off x="548640" y="3566160"/>
-            <a:ext cx="5486400" cy="1417320"/>
+            <a:off x="2734055" y="2148840"/>
+            <a:ext cx="2084831" cy="1737360"/>
           </a:xfrm>
           <a:prstGeom prst="roundRect">
             <a:avLst/>
@@ -6548,9 +6857,9 @@
           <a:solidFill>
             <a:srgbClr val="FFFFFF"/>
           </a:solidFill>
-          <a:ln w="22225">
+          <a:ln w="25400">
             <a:solidFill>
-              <a:srgbClr val="2D6CDF"/>
+              <a:srgbClr val="129E8F"/>
             </a:solidFill>
           </a:ln>
           <a:effectLst/>
@@ -6579,20 +6888,20 @@
       </p:sp>
       <p:sp>
         <p:nvSpPr>
-          <p:cNvPr id="11" name="Rectangle 10"/>
+          <p:cNvPr id="12" name="Rectangle 11"/>
           <p:cNvSpPr/>
           <p:nvPr/>
         </p:nvSpPr>
         <p:spPr>
           <a:xfrm>
-            <a:off x="548640" y="3566160"/>
-            <a:ext cx="118872" cy="1417320"/>
+            <a:off x="2734055" y="2148840"/>
+            <a:ext cx="2084831" cy="420624"/>
           </a:xfrm>
           <a:prstGeom prst="rect">
             <a:avLst/>
           </a:prstGeom>
           <a:solidFill>
-            <a:srgbClr val="2D6CDF"/>
+            <a:srgbClr val="129E8F"/>
           </a:solidFill>
           <a:ln>
             <a:noFill/>
@@ -6614,23 +6923,39 @@
           </a:fontRef>
         </p:style>
         <p:txBody>
-          <a:bodyPr rtlCol="0" anchor="ctr"/>
-          <a:lstStyle/>
-          <a:p>
-            <a:pPr algn="ctr"/>
-          </a:p>
-        </p:txBody>
-      </p:sp>
-      <p:sp>
-        <p:nvSpPr>
-          <p:cNvPr id="12" name="TextBox 11"/>
+          <a:bodyPr rtlCol="0" anchor="ctr" wrap="square"/>
+          <a:lstStyle/>
+          <a:p>
+            <a:pPr algn="ctr">
+              <a:lnSpc>
+                <a:spcPct val="103000"/>
+              </a:lnSpc>
+              <a:spcAft>
+                <a:spcPts val="0"/>
+              </a:spcAft>
+            </a:pPr>
+            <a:r>
+              <a:rPr sz="1250" b="1">
+                <a:solidFill>
+                  <a:srgbClr val="FFFFFF"/>
+                </a:solidFill>
+                <a:latin typeface="Calibri"/>
+              </a:rPr>
+              <a:t>2  CAPTURE</a:t>
+            </a:r>
+          </a:p>
+        </p:txBody>
+      </p:sp>
+      <p:sp>
+        <p:nvSpPr>
+          <p:cNvPr id="13" name="TextBox 12"/>
           <p:cNvSpPr txBox="1"/>
           <p:nvPr/>
         </p:nvSpPr>
         <p:spPr>
           <a:xfrm>
-            <a:off x="841248" y="3712464"/>
-            <a:ext cx="4983480" cy="1143000"/>
+            <a:off x="2898647" y="2660904"/>
+            <a:ext cx="1755647" cy="1133856"/>
           </a:xfrm>
           <a:prstGeom prst="rect">
             <a:avLst/>
@@ -6648,56 +6973,273 @@
                 <a:spcPct val="103000"/>
               </a:lnSpc>
               <a:spcAft>
-                <a:spcPts val="500"/>
-              </a:spcAft>
-            </a:pPr>
-            <a:r>
-              <a:rPr sz="1500" b="1">
-                <a:solidFill>
-                  <a:srgbClr val="2D6CDF"/>
-                </a:solidFill>
-                <a:latin typeface="Calibri"/>
-              </a:rPr>
-              <a:t>Latency</a:t>
-            </a:r>
-          </a:p>
-          <a:p>
-            <a:pPr algn="l">
-              <a:lnSpc>
-                <a:spcPct val="103000"/>
-              </a:lnSpc>
-              <a:spcAft>
-                <a:spcPts val="500"/>
-              </a:spcAft>
-            </a:pPr>
-            <a:r>
-              <a:rPr sz="1300" b="0">
+                <a:spcPts val="0"/>
+              </a:spcAft>
+            </a:pPr>
+            <a:r>
+              <a:rPr sz="1200" b="0">
                 <a:solidFill>
                   <a:srgbClr val="1A1F2B"/>
                 </a:solidFill>
                 <a:latin typeface="Calibri"/>
               </a:rPr>
-              <a:t>Ops reads it as an SLA. PM reads it as user-perceived responsiveness.</a:t>
-            </a:r>
-          </a:p>
-        </p:txBody>
-      </p:sp>
-      <p:sp>
-        <p:nvSpPr>
-          <p:cNvPr id="13" name="Rounded Rectangle 12"/>
+              <a:t>Dump each output to a review file with its expected behavior.</a:t>
+            </a:r>
+          </a:p>
+        </p:txBody>
+      </p:sp>
+      <p:sp>
+        <p:nvSpPr>
+          <p:cNvPr id="14" name="Right Arrow 13"/>
           <p:cNvSpPr/>
           <p:nvPr/>
         </p:nvSpPr>
         <p:spPr>
           <a:xfrm>
-            <a:off x="6309360" y="1965960"/>
-            <a:ext cx="5349240" cy="3931920"/>
+            <a:off x="4819386" y="2788920"/>
+            <a:ext cx="145304" cy="365760"/>
+          </a:xfrm>
+          <a:prstGeom prst="rightArrow">
+            <a:avLst/>
+          </a:prstGeom>
+          <a:solidFill>
+            <a:srgbClr val="E08A1E"/>
+          </a:solidFill>
+          <a:ln>
+            <a:noFill/>
+          </a:ln>
+          <a:effectLst/>
+        </p:spPr>
+        <p:style>
+          <a:lnRef idx="1">
+            <a:schemeClr val="accent1"/>
+          </a:lnRef>
+          <a:fillRef idx="3">
+            <a:schemeClr val="accent1"/>
+          </a:fillRef>
+          <a:effectRef idx="2">
+            <a:schemeClr val="accent1"/>
+          </a:effectRef>
+          <a:fontRef idx="minor">
+            <a:schemeClr val="lt1"/>
+          </a:fontRef>
+        </p:style>
+        <p:txBody>
+          <a:bodyPr rtlCol="0" anchor="ctr"/>
+          <a:lstStyle/>
+          <a:p>
+            <a:pPr algn="ctr"/>
+          </a:p>
+        </p:txBody>
+      </p:sp>
+      <p:sp>
+        <p:nvSpPr>
+          <p:cNvPr id="15" name="Rounded Rectangle 14"/>
+          <p:cNvSpPr/>
+          <p:nvPr/>
+        </p:nvSpPr>
+        <p:spPr>
+          <a:xfrm>
+            <a:off x="4965190" y="2148840"/>
+            <a:ext cx="2084831" cy="1737360"/>
           </a:xfrm>
           <a:prstGeom prst="roundRect">
             <a:avLst/>
           </a:prstGeom>
           <a:solidFill>
-            <a:srgbClr val="F2F5FA"/>
+            <a:srgbClr val="FFFFFF"/>
+          </a:solidFill>
+          <a:ln w="25400">
+            <a:solidFill>
+              <a:srgbClr val="6B4EC4"/>
+            </a:solidFill>
+          </a:ln>
+          <a:effectLst/>
+        </p:spPr>
+        <p:style>
+          <a:lnRef idx="1">
+            <a:schemeClr val="accent1"/>
+          </a:lnRef>
+          <a:fillRef idx="3">
+            <a:schemeClr val="accent1"/>
+          </a:fillRef>
+          <a:effectRef idx="2">
+            <a:schemeClr val="accent1"/>
+          </a:effectRef>
+          <a:fontRef idx="minor">
+            <a:schemeClr val="lt1"/>
+          </a:fontRef>
+        </p:style>
+        <p:txBody>
+          <a:bodyPr rtlCol="0" anchor="ctr"/>
+          <a:lstStyle/>
+          <a:p>
+            <a:pPr algn="ctr"/>
+          </a:p>
+        </p:txBody>
+      </p:sp>
+      <p:sp>
+        <p:nvSpPr>
+          <p:cNvPr id="16" name="Rectangle 15"/>
+          <p:cNvSpPr/>
+          <p:nvPr/>
+        </p:nvSpPr>
+        <p:spPr>
+          <a:xfrm>
+            <a:off x="4965190" y="2148840"/>
+            <a:ext cx="2084831" cy="420624"/>
+          </a:xfrm>
+          <a:prstGeom prst="rect">
+            <a:avLst/>
+          </a:prstGeom>
+          <a:solidFill>
+            <a:srgbClr val="6B4EC4"/>
+          </a:solidFill>
+          <a:ln>
+            <a:noFill/>
+          </a:ln>
+          <a:effectLst/>
+        </p:spPr>
+        <p:style>
+          <a:lnRef idx="1">
+            <a:schemeClr val="accent1"/>
+          </a:lnRef>
+          <a:fillRef idx="3">
+            <a:schemeClr val="accent1"/>
+          </a:fillRef>
+          <a:effectRef idx="2">
+            <a:schemeClr val="accent1"/>
+          </a:effectRef>
+          <a:fontRef idx="minor">
+            <a:schemeClr val="lt1"/>
+          </a:fontRef>
+        </p:style>
+        <p:txBody>
+          <a:bodyPr rtlCol="0" anchor="ctr" wrap="square"/>
+          <a:lstStyle/>
+          <a:p>
+            <a:pPr algn="ctr">
+              <a:lnSpc>
+                <a:spcPct val="103000"/>
+              </a:lnSpc>
+              <a:spcAft>
+                <a:spcPts val="0"/>
+              </a:spcAft>
+            </a:pPr>
+            <a:r>
+              <a:rPr sz="1250" b="1">
+                <a:solidFill>
+                  <a:srgbClr val="FFFFFF"/>
+                </a:solidFill>
+                <a:latin typeface="Calibri"/>
+              </a:rPr>
+              <a:t>3  LABEL</a:t>
+            </a:r>
+          </a:p>
+        </p:txBody>
+      </p:sp>
+      <p:sp>
+        <p:nvSpPr>
+          <p:cNvPr id="17" name="TextBox 16"/>
+          <p:cNvSpPr txBox="1"/>
+          <p:nvPr/>
+        </p:nvSpPr>
+        <p:spPr>
+          <a:xfrm>
+            <a:off x="5129782" y="2660904"/>
+            <a:ext cx="1755647" cy="1133856"/>
+          </a:xfrm>
+          <a:prstGeom prst="rect">
+            <a:avLst/>
+          </a:prstGeom>
+          <a:noFill/>
+        </p:spPr>
+        <p:txBody>
+          <a:bodyPr wrap="square" anchor="t">
+            <a:spAutoFit/>
+          </a:bodyPr>
+          <a:lstStyle/>
+          <a:p>
+            <a:pPr algn="l">
+              <a:lnSpc>
+                <a:spcPct val="103000"/>
+              </a:lnSpc>
+              <a:spcAft>
+                <a:spcPts val="0"/>
+              </a:spcAft>
+            </a:pPr>
+            <a:r>
+              <a:rPr sz="1200" b="0">
+                <a:solidFill>
+                  <a:srgbClr val="1A1F2B"/>
+                </a:solidFill>
+                <a:latin typeface="Calibri"/>
+              </a:rPr>
+              <a:t>Human reads output + rule, marks PASS / FAIL + one-line reason.</a:t>
+            </a:r>
+          </a:p>
+        </p:txBody>
+      </p:sp>
+      <p:sp>
+        <p:nvSpPr>
+          <p:cNvPr id="18" name="Right Arrow 17"/>
+          <p:cNvSpPr/>
+          <p:nvPr/>
+        </p:nvSpPr>
+        <p:spPr>
+          <a:xfrm>
+            <a:off x="7050521" y="2788920"/>
+            <a:ext cx="145304" cy="365760"/>
+          </a:xfrm>
+          <a:prstGeom prst="rightArrow">
+            <a:avLst/>
+          </a:prstGeom>
+          <a:solidFill>
+            <a:srgbClr val="E08A1E"/>
+          </a:solidFill>
+          <a:ln>
+            <a:noFill/>
+          </a:ln>
+          <a:effectLst/>
+        </p:spPr>
+        <p:style>
+          <a:lnRef idx="1">
+            <a:schemeClr val="accent1"/>
+          </a:lnRef>
+          <a:fillRef idx="3">
+            <a:schemeClr val="accent1"/>
+          </a:fillRef>
+          <a:effectRef idx="2">
+            <a:schemeClr val="accent1"/>
+          </a:effectRef>
+          <a:fontRef idx="minor">
+            <a:schemeClr val="lt1"/>
+          </a:fontRef>
+        </p:style>
+        <p:txBody>
+          <a:bodyPr rtlCol="0" anchor="ctr"/>
+          <a:lstStyle/>
+          <a:p>
+            <a:pPr algn="ctr"/>
+          </a:p>
+        </p:txBody>
+      </p:sp>
+      <p:sp>
+        <p:nvSpPr>
+          <p:cNvPr id="19" name="Rounded Rectangle 18"/>
+          <p:cNvSpPr/>
+          <p:nvPr/>
+        </p:nvSpPr>
+        <p:spPr>
+          <a:xfrm>
+            <a:off x="7196325" y="2148840"/>
+            <a:ext cx="2084831" cy="1737360"/>
+          </a:xfrm>
+          <a:prstGeom prst="roundRect">
+            <a:avLst/>
+          </a:prstGeom>
+          <a:solidFill>
+            <a:srgbClr val="FFFFFF"/>
           </a:solidFill>
           <a:ln w="25400">
             <a:solidFill>
@@ -6721,117 +7263,25 @@
           </a:fontRef>
         </p:style>
         <p:txBody>
-          <a:bodyPr rtlCol="0" anchor="t" wrap="square" lIns="292608" rIns="256032" tIns="256032"/>
-          <a:lstStyle/>
-          <a:p>
-            <a:pPr algn="l">
-              <a:lnSpc>
-                <a:spcPct val="103000"/>
-              </a:lnSpc>
-              <a:spcAft>
-                <a:spcPts val="900"/>
-              </a:spcAft>
-            </a:pPr>
-            <a:r>
-              <a:rPr sz="1600" b="1">
-                <a:solidFill>
-                  <a:srgbClr val="1A1F2B"/>
-                </a:solidFill>
-                <a:latin typeface="Calibri"/>
-              </a:rPr>
-              <a:t>One number ≠ one meaning.</a:t>
-            </a:r>
-          </a:p>
-          <a:p>
-            <a:pPr algn="l">
-              <a:lnSpc>
-                <a:spcPct val="103000"/>
-              </a:lnSpc>
-              <a:spcAft>
-                <a:spcPts val="900"/>
-              </a:spcAft>
-            </a:pPr>
-            <a:r>
-              <a:rPr sz="1400" b="0">
-                <a:solidFill>
-                  <a:srgbClr val="5B6470"/>
-                </a:solidFill>
-                <a:latin typeface="Calibri"/>
-              </a:rPr>
-              <a:t>The metric is shared; the interpretation and the threshold are not.</a:t>
-            </a:r>
-          </a:p>
-          <a:p>
-            <a:pPr algn="l">
-              <a:lnSpc>
-                <a:spcPct val="103000"/>
-              </a:lnSpc>
-              <a:spcAft>
-                <a:spcPts val="900"/>
-              </a:spcAft>
-            </a:pPr>
-            <a:r>
-              <a:rPr sz="600" b="0">
-                <a:solidFill>
-                  <a:srgbClr val="5B6470"/>
-                </a:solidFill>
-                <a:latin typeface="Calibri"/>
-              </a:rPr>
-              <a:t/>
-            </a:r>
-          </a:p>
-          <a:p>
-            <a:pPr algn="l">
-              <a:lnSpc>
-                <a:spcPct val="103000"/>
-              </a:lnSpc>
-              <a:spcAft>
-                <a:spcPts val="900"/>
-              </a:spcAft>
-            </a:pPr>
-            <a:r>
-              <a:rPr sz="1500" b="1">
-                <a:solidFill>
-                  <a:srgbClr val="E08A1E"/>
-                </a:solidFill>
-                <a:latin typeface="Calibri"/>
-              </a:rPr>
-              <a:t>A persona view = metric + interpretation + threshold</a:t>
-            </a:r>
-          </a:p>
-          <a:p>
-            <a:pPr algn="l">
-              <a:lnSpc>
-                <a:spcPct val="103000"/>
-              </a:lnSpc>
-              <a:spcAft>
-                <a:spcPts val="900"/>
-              </a:spcAft>
-            </a:pPr>
-            <a:r>
-              <a:rPr sz="1350" b="0">
-                <a:solidFill>
-                  <a:srgbClr val="1A1F2B"/>
-                </a:solidFill>
-                <a:latin typeface="Calibri"/>
-              </a:rPr>
-              <a:t>…not just a filtered column list. Don’t assume a shared definition just because you share a column header.</a:t>
-            </a:r>
-          </a:p>
-        </p:txBody>
-      </p:sp>
-      <p:sp>
-        <p:nvSpPr>
-          <p:cNvPr id="14" name="Rounded Rectangle 13"/>
+          <a:bodyPr rtlCol="0" anchor="ctr"/>
+          <a:lstStyle/>
+          <a:p>
+            <a:pPr algn="ctr"/>
+          </a:p>
+        </p:txBody>
+      </p:sp>
+      <p:sp>
+        <p:nvSpPr>
+          <p:cNvPr id="20" name="Rectangle 19"/>
           <p:cNvSpPr/>
           <p:nvPr/>
         </p:nvSpPr>
         <p:spPr>
           <a:xfrm>
-            <a:off x="6601968" y="2148840"/>
-            <a:ext cx="3108960" cy="384048"/>
-          </a:xfrm>
-          <a:prstGeom prst="roundRect">
+            <a:off x="7196325" y="2148840"/>
+            <a:ext cx="2084831" cy="420624"/>
+          </a:xfrm>
+          <a:prstGeom prst="rect">
             <a:avLst/>
           </a:prstGeom>
           <a:solidFill>
@@ -6869,13 +7319,503 @@
               </a:spcAft>
             </a:pPr>
             <a:r>
-              <a:rPr sz="1200" b="1">
+              <a:rPr sz="1250" b="1">
                 <a:solidFill>
                   <a:srgbClr val="FFFFFF"/>
                 </a:solidFill>
                 <a:latin typeface="Calibri"/>
               </a:rPr>
-              <a:t>THE TRAP</a:t>
+              <a:t>4  SCORE</a:t>
+            </a:r>
+          </a:p>
+        </p:txBody>
+      </p:sp>
+      <p:sp>
+        <p:nvSpPr>
+          <p:cNvPr id="21" name="TextBox 20"/>
+          <p:cNvSpPr txBox="1"/>
+          <p:nvPr/>
+        </p:nvSpPr>
+        <p:spPr>
+          <a:xfrm>
+            <a:off x="7360917" y="2660904"/>
+            <a:ext cx="1755647" cy="1133856"/>
+          </a:xfrm>
+          <a:prstGeom prst="rect">
+            <a:avLst/>
+          </a:prstGeom>
+          <a:noFill/>
+        </p:spPr>
+        <p:txBody>
+          <a:bodyPr wrap="square" anchor="t">
+            <a:spAutoFit/>
+          </a:bodyPr>
+          <a:lstStyle/>
+          <a:p>
+            <a:pPr algn="l">
+              <a:lnSpc>
+                <a:spcPct val="103000"/>
+              </a:lnSpc>
+              <a:spcAft>
+                <a:spcPts val="0"/>
+              </a:spcAft>
+            </a:pPr>
+            <a:r>
+              <a:rPr sz="1200" b="0">
+                <a:solidFill>
+                  <a:srgbClr val="1A1F2B"/>
+                </a:solidFill>
+                <a:latin typeface="Calibri"/>
+              </a:rPr>
+              <a:t>Run the judge on the same cases; compare to the human labels.</a:t>
+            </a:r>
+          </a:p>
+        </p:txBody>
+      </p:sp>
+      <p:sp>
+        <p:nvSpPr>
+          <p:cNvPr id="22" name="Right Arrow 21"/>
+          <p:cNvSpPr/>
+          <p:nvPr/>
+        </p:nvSpPr>
+        <p:spPr>
+          <a:xfrm>
+            <a:off x="9281656" y="2788920"/>
+            <a:ext cx="145304" cy="365760"/>
+          </a:xfrm>
+          <a:prstGeom prst="rightArrow">
+            <a:avLst/>
+          </a:prstGeom>
+          <a:solidFill>
+            <a:srgbClr val="E08A1E"/>
+          </a:solidFill>
+          <a:ln>
+            <a:noFill/>
+          </a:ln>
+          <a:effectLst/>
+        </p:spPr>
+        <p:style>
+          <a:lnRef idx="1">
+            <a:schemeClr val="accent1"/>
+          </a:lnRef>
+          <a:fillRef idx="3">
+            <a:schemeClr val="accent1"/>
+          </a:fillRef>
+          <a:effectRef idx="2">
+            <a:schemeClr val="accent1"/>
+          </a:effectRef>
+          <a:fontRef idx="minor">
+            <a:schemeClr val="lt1"/>
+          </a:fontRef>
+        </p:style>
+        <p:txBody>
+          <a:bodyPr rtlCol="0" anchor="ctr"/>
+          <a:lstStyle/>
+          <a:p>
+            <a:pPr algn="ctr"/>
+          </a:p>
+        </p:txBody>
+      </p:sp>
+      <p:sp>
+        <p:nvSpPr>
+          <p:cNvPr id="23" name="Rounded Rectangle 22"/>
+          <p:cNvSpPr/>
+          <p:nvPr/>
+        </p:nvSpPr>
+        <p:spPr>
+          <a:xfrm>
+            <a:off x="9427460" y="2148840"/>
+            <a:ext cx="2084831" cy="1737360"/>
+          </a:xfrm>
+          <a:prstGeom prst="roundRect">
+            <a:avLst/>
+          </a:prstGeom>
+          <a:solidFill>
+            <a:srgbClr val="FFFFFF"/>
+          </a:solidFill>
+          <a:ln w="25400">
+            <a:solidFill>
+              <a:srgbClr val="0F2A4A"/>
+            </a:solidFill>
+          </a:ln>
+          <a:effectLst/>
+        </p:spPr>
+        <p:style>
+          <a:lnRef idx="1">
+            <a:schemeClr val="accent1"/>
+          </a:lnRef>
+          <a:fillRef idx="3">
+            <a:schemeClr val="accent1"/>
+          </a:fillRef>
+          <a:effectRef idx="2">
+            <a:schemeClr val="accent1"/>
+          </a:effectRef>
+          <a:fontRef idx="minor">
+            <a:schemeClr val="lt1"/>
+          </a:fontRef>
+        </p:style>
+        <p:txBody>
+          <a:bodyPr rtlCol="0" anchor="ctr"/>
+          <a:lstStyle/>
+          <a:p>
+            <a:pPr algn="ctr"/>
+          </a:p>
+        </p:txBody>
+      </p:sp>
+      <p:sp>
+        <p:nvSpPr>
+          <p:cNvPr id="24" name="Rectangle 23"/>
+          <p:cNvSpPr/>
+          <p:nvPr/>
+        </p:nvSpPr>
+        <p:spPr>
+          <a:xfrm>
+            <a:off x="9427460" y="2148840"/>
+            <a:ext cx="2084831" cy="420624"/>
+          </a:xfrm>
+          <a:prstGeom prst="rect">
+            <a:avLst/>
+          </a:prstGeom>
+          <a:solidFill>
+            <a:srgbClr val="0F2A4A"/>
+          </a:solidFill>
+          <a:ln>
+            <a:noFill/>
+          </a:ln>
+          <a:effectLst/>
+        </p:spPr>
+        <p:style>
+          <a:lnRef idx="1">
+            <a:schemeClr val="accent1"/>
+          </a:lnRef>
+          <a:fillRef idx="3">
+            <a:schemeClr val="accent1"/>
+          </a:fillRef>
+          <a:effectRef idx="2">
+            <a:schemeClr val="accent1"/>
+          </a:effectRef>
+          <a:fontRef idx="minor">
+            <a:schemeClr val="lt1"/>
+          </a:fontRef>
+        </p:style>
+        <p:txBody>
+          <a:bodyPr rtlCol="0" anchor="ctr" wrap="square"/>
+          <a:lstStyle/>
+          <a:p>
+            <a:pPr algn="ctr">
+              <a:lnSpc>
+                <a:spcPct val="103000"/>
+              </a:lnSpc>
+              <a:spcAft>
+                <a:spcPts val="0"/>
+              </a:spcAft>
+            </a:pPr>
+            <a:r>
+              <a:rPr sz="1250" b="1">
+                <a:solidFill>
+                  <a:srgbClr val="FFFFFF"/>
+                </a:solidFill>
+                <a:latin typeface="Calibri"/>
+              </a:rPr>
+              <a:t>5  FOLD BACK</a:t>
+            </a:r>
+          </a:p>
+        </p:txBody>
+      </p:sp>
+      <p:sp>
+        <p:nvSpPr>
+          <p:cNvPr id="25" name="TextBox 24"/>
+          <p:cNvSpPr txBox="1"/>
+          <p:nvPr/>
+        </p:nvSpPr>
+        <p:spPr>
+          <a:xfrm>
+            <a:off x="9592052" y="2660904"/>
+            <a:ext cx="1755647" cy="1133856"/>
+          </a:xfrm>
+          <a:prstGeom prst="rect">
+            <a:avLst/>
+          </a:prstGeom>
+          <a:noFill/>
+        </p:spPr>
+        <p:txBody>
+          <a:bodyPr wrap="square" anchor="t">
+            <a:spAutoFit/>
+          </a:bodyPr>
+          <a:lstStyle/>
+          <a:p>
+            <a:pPr algn="l">
+              <a:lnSpc>
+                <a:spcPct val="103000"/>
+              </a:lnSpc>
+              <a:spcAft>
+                <a:spcPts val="0"/>
+              </a:spcAft>
+            </a:pPr>
+            <a:r>
+              <a:rPr sz="1200" b="0">
+                <a:solidFill>
+                  <a:srgbClr val="1A1F2B"/>
+                </a:solidFill>
+                <a:latin typeface="Calibri"/>
+              </a:rPr>
+              <a:t>Labels become the benchmark; re-run as the judge/prompts change.</a:t>
+            </a:r>
+          </a:p>
+        </p:txBody>
+      </p:sp>
+      <p:sp>
+        <p:nvSpPr>
+          <p:cNvPr id="26" name="Rounded Rectangle 25"/>
+          <p:cNvSpPr/>
+          <p:nvPr/>
+        </p:nvSpPr>
+        <p:spPr>
+          <a:xfrm>
+            <a:off x="502920" y="4251960"/>
+            <a:ext cx="5486400" cy="1874519"/>
+          </a:xfrm>
+          <a:prstGeom prst="roundRect">
+            <a:avLst/>
+          </a:prstGeom>
+          <a:solidFill>
+            <a:srgbClr val="FDF3E2"/>
+          </a:solidFill>
+          <a:ln w="25400">
+            <a:solidFill>
+              <a:srgbClr val="C0392B"/>
+            </a:solidFill>
+          </a:ln>
+          <a:effectLst/>
+        </p:spPr>
+        <p:style>
+          <a:lnRef idx="1">
+            <a:schemeClr val="accent1"/>
+          </a:lnRef>
+          <a:fillRef idx="3">
+            <a:schemeClr val="accent1"/>
+          </a:fillRef>
+          <a:effectRef idx="2">
+            <a:schemeClr val="accent1"/>
+          </a:effectRef>
+          <a:fontRef idx="minor">
+            <a:schemeClr val="lt1"/>
+          </a:fontRef>
+        </p:style>
+        <p:txBody>
+          <a:bodyPr rtlCol="0" anchor="t" wrap="square" lIns="274320" tIns="182880"/>
+          <a:lstStyle/>
+          <a:p>
+            <a:pPr algn="l">
+              <a:lnSpc>
+                <a:spcPct val="103000"/>
+              </a:lnSpc>
+              <a:spcAft>
+                <a:spcPts val="600"/>
+              </a:spcAft>
+            </a:pPr>
+            <a:r>
+              <a:rPr sz="1500" b="1">
+                <a:solidFill>
+                  <a:srgbClr val="C0392B"/>
+                </a:solidFill>
+                <a:latin typeface="Calibri"/>
+              </a:rPr>
+              <a:t>Watch the false positives</a:t>
+            </a:r>
+          </a:p>
+          <a:p>
+            <a:pPr algn="l">
+              <a:lnSpc>
+                <a:spcPct val="103000"/>
+              </a:lnSpc>
+              <a:spcAft>
+                <a:spcPts val="600"/>
+              </a:spcAft>
+            </a:pPr>
+            <a:r>
+              <a:rPr sz="1350" b="0">
+                <a:solidFill>
+                  <a:srgbClr val="1A1F2B"/>
+                </a:solidFill>
+                <a:latin typeface="Calibri"/>
+              </a:rPr>
+              <a:t>The dangerous error is the judge passing an output a human failed — a silent quality miss. Track those, not just overall accuracy.</a:t>
+            </a:r>
+          </a:p>
+          <a:p>
+            <a:pPr algn="l">
+              <a:lnSpc>
+                <a:spcPct val="103000"/>
+              </a:lnSpc>
+              <a:spcAft>
+                <a:spcPts val="600"/>
+              </a:spcAft>
+            </a:pPr>
+            <a:r>
+              <a:rPr sz="500" b="0">
+                <a:solidFill>
+                  <a:srgbClr val="5B6470"/>
+                </a:solidFill>
+                <a:latin typeface="Calibri"/>
+              </a:rPr>
+              <a:t/>
+            </a:r>
+          </a:p>
+          <a:p>
+            <a:pPr algn="l">
+              <a:lnSpc>
+                <a:spcPct val="103000"/>
+              </a:lnSpc>
+              <a:spcAft>
+                <a:spcPts val="600"/>
+              </a:spcAft>
+            </a:pPr>
+            <a:r>
+              <a:rPr sz="1250" b="1">
+                <a:solidFill>
+                  <a:srgbClr val="0F2A4A"/>
+                </a:solidFill>
+                <a:latin typeface="Calibri"/>
+              </a:rPr>
+              <a:t>Confusion matrix, human vs judge:</a:t>
+            </a:r>
+            <a:r>
+              <a:rPr sz="1250" b="0">
+                <a:solidFill>
+                  <a:srgbClr val="1A1F2B"/>
+                </a:solidFill>
+                <a:latin typeface="Calibri"/>
+              </a:rPr>
+              <a:t>  pass/pass, fail/fail = agree;  fail→pass = false positive.</a:t>
+            </a:r>
+          </a:p>
+        </p:txBody>
+      </p:sp>
+      <p:sp>
+        <p:nvSpPr>
+          <p:cNvPr id="27" name="Rounded Rectangle 26"/>
+          <p:cNvSpPr/>
+          <p:nvPr/>
+        </p:nvSpPr>
+        <p:spPr>
+          <a:xfrm>
+            <a:off x="6172200" y="4251960"/>
+            <a:ext cx="5486400" cy="1874519"/>
+          </a:xfrm>
+          <a:prstGeom prst="roundRect">
+            <a:avLst/>
+          </a:prstGeom>
+          <a:solidFill>
+            <a:srgbClr val="F2F5FA"/>
+          </a:solidFill>
+          <a:ln w="19050">
+            <a:solidFill>
+              <a:srgbClr val="6B4EC4"/>
+            </a:solidFill>
+          </a:ln>
+          <a:effectLst/>
+        </p:spPr>
+        <p:style>
+          <a:lnRef idx="1">
+            <a:schemeClr val="accent1"/>
+          </a:lnRef>
+          <a:fillRef idx="3">
+            <a:schemeClr val="accent1"/>
+          </a:fillRef>
+          <a:effectRef idx="2">
+            <a:schemeClr val="accent1"/>
+          </a:effectRef>
+          <a:fontRef idx="minor">
+            <a:schemeClr val="lt1"/>
+          </a:fontRef>
+        </p:style>
+        <p:txBody>
+          <a:bodyPr rtlCol="0" anchor="t" wrap="square" lIns="274320" tIns="182880"/>
+          <a:lstStyle/>
+          <a:p>
+            <a:pPr algn="l">
+              <a:lnSpc>
+                <a:spcPct val="103000"/>
+              </a:lnSpc>
+              <a:spcAft>
+                <a:spcPts val="600"/>
+              </a:spcAft>
+            </a:pPr>
+            <a:r>
+              <a:rPr sz="1500" b="1">
+                <a:solidFill>
+                  <a:srgbClr val="6B4EC4"/>
+                </a:solidFill>
+                <a:latin typeface="Calibri"/>
+              </a:rPr>
+              <a:t>The human is the ground truth</a:t>
+            </a:r>
+          </a:p>
+          <a:p>
+            <a:pPr algn="l">
+              <a:lnSpc>
+                <a:spcPct val="103000"/>
+              </a:lnSpc>
+              <a:spcAft>
+                <a:spcPts val="600"/>
+              </a:spcAft>
+            </a:pPr>
+            <a:r>
+              <a:rPr sz="1350" b="0">
+                <a:solidFill>
+                  <a:srgbClr val="1A1F2B"/>
+                </a:solidFill>
+                <a:latin typeface="Calibri"/>
+              </a:rPr>
+              <a:t>You grade against the case’s expected behavior — not “is this good analysis?” Cite specific evidence; when unsure, default to FAIL.</a:t>
+            </a:r>
+          </a:p>
+          <a:p>
+            <a:pPr algn="l">
+              <a:lnSpc>
+                <a:spcPct val="103000"/>
+              </a:lnSpc>
+              <a:spcAft>
+                <a:spcPts val="600"/>
+              </a:spcAft>
+            </a:pPr>
+            <a:r>
+              <a:rPr sz="500" b="0">
+                <a:solidFill>
+                  <a:srgbClr val="5B6470"/>
+                </a:solidFill>
+                <a:latin typeface="Calibri"/>
+              </a:rPr>
+              <a:t/>
+            </a:r>
+          </a:p>
+          <a:p>
+            <a:pPr algn="l">
+              <a:lnSpc>
+                <a:spcPct val="103000"/>
+              </a:lnSpc>
+              <a:spcAft>
+                <a:spcPts val="600"/>
+              </a:spcAft>
+            </a:pPr>
+            <a:r>
+              <a:rPr sz="1250" b="1">
+                <a:solidFill>
+                  <a:srgbClr val="0F2A4A"/>
+                </a:solidFill>
+                <a:latin typeface="Calibri"/>
+              </a:rPr>
+              <a:t>Seed labels are synthetic</a:t>
+            </a:r>
+            <a:r>
+              <a:rPr sz="1250" b="0">
+                <a:solidFill>
+                  <a:srgbClr val="1A1F2B"/>
+                </a:solidFill>
+                <a:latin typeface="Calibri"/>
+              </a:rPr>
+              <a:t> until replaced with human-labeled real outputs.</a:t>
             </a:r>
           </a:p>
         </p:txBody>
@@ -7067,7 +8007,7 @@
                 </a:solidFill>
                 <a:latin typeface="Calibri"/>
               </a:rPr>
-              <a:t>CAUTION 3</a:t>
+              <a:t>CAUTION 1</a:t>
             </a:r>
           </a:p>
           <a:p>
@@ -7086,7 +8026,7 @@
                 </a:solidFill>
                 <a:latin typeface="Calibri"/>
               </a:rPr>
-              <a:t>Persona is a different axis from lifecycle stage</a:t>
+              <a:t>Failures hide in the seams between personas</a:t>
             </a:r>
           </a:p>
         </p:txBody>
@@ -7106,7 +8046,7 @@
             <a:avLst/>
           </a:prstGeom>
           <a:solidFill>
-            <a:srgbClr val="6B4EC4"/>
+            <a:srgbClr val="C0392B"/>
           </a:solidFill>
           <a:ln>
             <a:noFill/>
@@ -7146,7 +8086,7 @@
                 </a:solidFill>
                 <a:latin typeface="Calibri"/>
               </a:rPr>
-              <a:t>CAUTION 3</a:t>
+              <a:t>CAUTION 1</a:t>
             </a:r>
           </a:p>
         </p:txBody>
@@ -7170,7 +8110,7 @@
           </a:solidFill>
           <a:ln w="22225">
             <a:solidFill>
-              <a:srgbClr val="6B4EC4"/>
+              <a:srgbClr val="129E8F"/>
             </a:solidFill>
           </a:ln>
           <a:effectLst/>
@@ -7212,7 +8152,7 @@
             <a:avLst/>
           </a:prstGeom>
           <a:solidFill>
-            <a:srgbClr val="6B4EC4"/>
+            <a:srgbClr val="129E8F"/>
           </a:solidFill>
           <a:ln>
             <a:noFill/>
@@ -7274,11 +8214,11 @@
             <a:r>
               <a:rPr sz="1500" b="1">
                 <a:solidFill>
-                  <a:srgbClr val="6B4EC4"/>
-                </a:solidFill>
-                <a:latin typeface="Calibri"/>
-              </a:rPr>
-              <a:t>WHO  (persona)</a:t>
+                  <a:srgbClr val="129E8F"/>
+                </a:solidFill>
+                <a:latin typeface="Calibri"/>
+              </a:rPr>
+              <a:t>Engineer's view: Write Accuracy = 5/5</a:t>
             </a:r>
           </a:p>
           <a:p>
@@ -7297,7 +8237,7 @@
                 </a:solidFill>
                 <a:latin typeface="Calibri"/>
               </a:rPr>
-              <a:t>PM / Domain • App Engineer • Platform • SRE</a:t>
+              <a:t>“The output is consistent with the input it was given.”  → looks healthy.</a:t>
             </a:r>
           </a:p>
         </p:txBody>
@@ -7321,7 +8261,7 @@
           </a:solidFill>
           <a:ln w="22225">
             <a:solidFill>
-              <a:srgbClr val="2D6CDF"/>
+              <a:srgbClr val="C0392B"/>
             </a:solidFill>
           </a:ln>
           <a:effectLst/>
@@ -7363,7 +8303,7 @@
             <a:avLst/>
           </a:prstGeom>
           <a:solidFill>
-            <a:srgbClr val="2D6CDF"/>
+            <a:srgbClr val="C0392B"/>
           </a:solidFill>
           <a:ln>
             <a:noFill/>
@@ -7425,11 +8365,11 @@
             <a:r>
               <a:rPr sz="1500" b="1">
                 <a:solidFill>
-                  <a:srgbClr val="2D6CDF"/>
-                </a:solidFill>
-                <a:latin typeface="Calibri"/>
-              </a:rPr>
-              <a:t>WHEN  (stage)</a:t>
+                  <a:srgbClr val="C0392B"/>
+                </a:solidFill>
+                <a:latin typeface="Calibri"/>
+              </a:rPr>
+              <a:t>PM's view: Groundedness = 2/5</a:t>
             </a:r>
           </a:p>
           <a:p>
@@ -7448,7 +8388,7 @@
                 </a:solidFill>
                 <a:latin typeface="Calibri"/>
               </a:rPr>
-              <a:t>Design • Code • Deploy • Operate</a:t>
+              <a:t>“The output does not match reality — the input premise was wrong.”  → broken.</a:t>
             </a:r>
           </a:p>
         </p:txBody>
@@ -7472,7 +8412,7 @@
           </a:solidFill>
           <a:ln w="25400">
             <a:solidFill>
-              <a:srgbClr val="6B4EC4"/>
+              <a:srgbClr val="C0392B"/>
             </a:solidFill>
           </a:ln>
           <a:effectLst/>
@@ -7510,7 +8450,7 @@
                 </a:solidFill>
                 <a:latin typeface="Calibri"/>
               </a:rPr>
-              <a:t>They correlate — but they are not the same axis.</a:t>
+              <a:t>Same agent. Same turn. Two personas, opposite verdicts.</a:t>
             </a:r>
           </a:p>
           <a:p>
@@ -7529,7 +8469,7 @@
                 </a:solidFill>
                 <a:latin typeface="Calibri"/>
               </a:rPr>
-              <a:t>Groundedness is not “design-only.” It is a design-time gate AND a production canary (e.g. drift after a model swap).</a:t>
+              <a:t>If each persona reads only their own column, nobody owns the seam — and the seam is exactly where the failure lives.</a:t>
             </a:r>
           </a:p>
           <a:p>
@@ -7563,11 +8503,11 @@
             <a:r>
               <a:rPr sz="1500" b="1">
                 <a:solidFill>
-                  <a:srgbClr val="6B4EC4"/>
-                </a:solidFill>
-                <a:latin typeface="Calibri"/>
-              </a:rPr>
-              <a:t>Keep two axes: who + when.</a:t>
+                  <a:srgbClr val="C0392B"/>
+                </a:solidFill>
+                <a:latin typeface="Calibri"/>
+              </a:rPr>
+              <a:t>Personas are lenses, not owners.</a:t>
             </a:r>
           </a:p>
           <a:p>
@@ -7586,7 +8526,7 @@
                 </a:solidFill>
                 <a:latin typeface="Calibri"/>
               </a:rPr>
-              <a:t>The same metric recurs at multiple stages with different urgency. Collapsing the axes makes coverage look complete when it isn’t.</a:t>
+              <a:t>Everyone gets a home dashboard, but quality gates require a cross-persona read. Partitioning improves triage; taken as strict ownership it worsens detection.</a:t>
             </a:r>
           </a:p>
         </p:txBody>
@@ -7606,7 +8546,7 @@
             <a:avLst/>
           </a:prstGeom>
           <a:solidFill>
-            <a:srgbClr val="6B4EC4"/>
+            <a:srgbClr val="C0392B"/>
           </a:solidFill>
           <a:ln>
             <a:noFill/>
@@ -7660,6 +8600,1548 @@
 </file>
 
 <file path=ppt/slides/slide7.xml><?xml version="1.0" encoding="utf-8"?>
+<p:sld xmlns:a="http://schemas.openxmlformats.org/drawingml/2006/main" xmlns:p="http://schemas.openxmlformats.org/presentationml/2006/main" xmlns:r="http://schemas.openxmlformats.org/officeDocument/2006/relationships">
+  <p:cSld>
+    <p:spTree>
+      <p:nvGrpSpPr>
+        <p:cNvPr id="1" name=""/>
+        <p:cNvGrpSpPr/>
+        <p:nvPr/>
+      </p:nvGrpSpPr>
+      <p:grpSpPr/>
+      <p:sp>
+        <p:nvSpPr>
+          <p:cNvPr id="2" name="Rectangle 1"/>
+          <p:cNvSpPr/>
+          <p:nvPr/>
+        </p:nvSpPr>
+        <p:spPr>
+          <a:xfrm>
+            <a:off x="0" y="0"/>
+            <a:ext cx="12191695" cy="6858000"/>
+          </a:xfrm>
+          <a:prstGeom prst="rect">
+            <a:avLst/>
+          </a:prstGeom>
+          <a:solidFill>
+            <a:srgbClr val="FFFFFF"/>
+          </a:solidFill>
+          <a:ln>
+            <a:noFill/>
+          </a:ln>
+          <a:effectLst/>
+        </p:spPr>
+        <p:style>
+          <a:lnRef idx="1">
+            <a:schemeClr val="accent1"/>
+          </a:lnRef>
+          <a:fillRef idx="3">
+            <a:schemeClr val="accent1"/>
+          </a:fillRef>
+          <a:effectRef idx="2">
+            <a:schemeClr val="accent1"/>
+          </a:effectRef>
+          <a:fontRef idx="minor">
+            <a:schemeClr val="lt1"/>
+          </a:fontRef>
+        </p:style>
+        <p:txBody>
+          <a:bodyPr rtlCol="0" anchor="ctr"/>
+          <a:lstStyle/>
+          <a:p>
+            <a:pPr algn="ctr"/>
+          </a:p>
+        </p:txBody>
+      </p:sp>
+      <p:sp>
+        <p:nvSpPr>
+          <p:cNvPr id="3" name="Rectangle 2"/>
+          <p:cNvSpPr/>
+          <p:nvPr/>
+        </p:nvSpPr>
+        <p:spPr>
+          <a:xfrm>
+            <a:off x="0" y="0"/>
+            <a:ext cx="12191695" cy="1097280"/>
+          </a:xfrm>
+          <a:prstGeom prst="rect">
+            <a:avLst/>
+          </a:prstGeom>
+          <a:solidFill>
+            <a:srgbClr val="0F2A4A"/>
+          </a:solidFill>
+          <a:ln>
+            <a:noFill/>
+          </a:ln>
+          <a:effectLst/>
+        </p:spPr>
+        <p:style>
+          <a:lnRef idx="1">
+            <a:schemeClr val="accent1"/>
+          </a:lnRef>
+          <a:fillRef idx="3">
+            <a:schemeClr val="accent1"/>
+          </a:fillRef>
+          <a:effectRef idx="2">
+            <a:schemeClr val="accent1"/>
+          </a:effectRef>
+          <a:fontRef idx="minor">
+            <a:schemeClr val="lt1"/>
+          </a:fontRef>
+        </p:style>
+        <p:txBody>
+          <a:bodyPr rtlCol="0" anchor="ctr"/>
+          <a:lstStyle/>
+          <a:p>
+            <a:pPr algn="ctr"/>
+          </a:p>
+        </p:txBody>
+      </p:sp>
+      <p:sp>
+        <p:nvSpPr>
+          <p:cNvPr id="4" name="Rectangle 3"/>
+          <p:cNvSpPr/>
+          <p:nvPr/>
+        </p:nvSpPr>
+        <p:spPr>
+          <a:xfrm>
+            <a:off x="0" y="1097280"/>
+            <a:ext cx="12191695" cy="54864"/>
+          </a:xfrm>
+          <a:prstGeom prst="rect">
+            <a:avLst/>
+          </a:prstGeom>
+          <a:solidFill>
+            <a:srgbClr val="2D6CDF"/>
+          </a:solidFill>
+          <a:ln>
+            <a:noFill/>
+          </a:ln>
+          <a:effectLst/>
+        </p:spPr>
+        <p:style>
+          <a:lnRef idx="1">
+            <a:schemeClr val="accent1"/>
+          </a:lnRef>
+          <a:fillRef idx="3">
+            <a:schemeClr val="accent1"/>
+          </a:fillRef>
+          <a:effectRef idx="2">
+            <a:schemeClr val="accent1"/>
+          </a:effectRef>
+          <a:fontRef idx="minor">
+            <a:schemeClr val="lt1"/>
+          </a:fontRef>
+        </p:style>
+        <p:txBody>
+          <a:bodyPr rtlCol="0" anchor="ctr"/>
+          <a:lstStyle/>
+          <a:p>
+            <a:pPr algn="ctr"/>
+          </a:p>
+        </p:txBody>
+      </p:sp>
+      <p:sp>
+        <p:nvSpPr>
+          <p:cNvPr id="5" name="TextBox 4"/>
+          <p:cNvSpPr txBox="1"/>
+          <p:nvPr/>
+        </p:nvSpPr>
+        <p:spPr>
+          <a:xfrm>
+            <a:off x="548640" y="128016"/>
+            <a:ext cx="11064240" cy="914400"/>
+          </a:xfrm>
+          <a:prstGeom prst="rect">
+            <a:avLst/>
+          </a:prstGeom>
+          <a:noFill/>
+        </p:spPr>
+        <p:txBody>
+          <a:bodyPr wrap="square" anchor="t">
+            <a:spAutoFit/>
+          </a:bodyPr>
+          <a:lstStyle/>
+          <a:p>
+            <a:pPr algn="l">
+              <a:lnSpc>
+                <a:spcPct val="103000"/>
+              </a:lnSpc>
+              <a:spcAft>
+                <a:spcPts val="200"/>
+              </a:spcAft>
+            </a:pPr>
+            <a:r>
+              <a:rPr sz="1200" b="1">
+                <a:solidFill>
+                  <a:srgbClr val="BFD0EA"/>
+                </a:solidFill>
+                <a:latin typeface="Calibri"/>
+              </a:rPr>
+              <a:t>CAUTION 2</a:t>
+            </a:r>
+          </a:p>
+          <a:p>
+            <a:pPr algn="l">
+              <a:lnSpc>
+                <a:spcPct val="103000"/>
+              </a:lnSpc>
+              <a:spcAft>
+                <a:spcPts val="200"/>
+              </a:spcAft>
+            </a:pPr>
+            <a:r>
+              <a:rPr sz="2700" b="1">
+                <a:solidFill>
+                  <a:srgbClr val="FFFFFF"/>
+                </a:solidFill>
+                <a:latin typeface="Calibri"/>
+              </a:rPr>
+              <a:t>The same metric means different things</a:t>
+            </a:r>
+          </a:p>
+        </p:txBody>
+      </p:sp>
+      <p:sp>
+        <p:nvSpPr>
+          <p:cNvPr id="6" name="Rounded Rectangle 5"/>
+          <p:cNvSpPr/>
+          <p:nvPr/>
+        </p:nvSpPr>
+        <p:spPr>
+          <a:xfrm>
+            <a:off x="548640" y="1325880"/>
+            <a:ext cx="2011680" cy="384048"/>
+          </a:xfrm>
+          <a:prstGeom prst="roundRect">
+            <a:avLst/>
+          </a:prstGeom>
+          <a:solidFill>
+            <a:srgbClr val="E08A1E"/>
+          </a:solidFill>
+          <a:ln>
+            <a:noFill/>
+          </a:ln>
+          <a:effectLst/>
+        </p:spPr>
+        <p:style>
+          <a:lnRef idx="1">
+            <a:schemeClr val="accent1"/>
+          </a:lnRef>
+          <a:fillRef idx="3">
+            <a:schemeClr val="accent1"/>
+          </a:fillRef>
+          <a:effectRef idx="2">
+            <a:schemeClr val="accent1"/>
+          </a:effectRef>
+          <a:fontRef idx="minor">
+            <a:schemeClr val="lt1"/>
+          </a:fontRef>
+        </p:style>
+        <p:txBody>
+          <a:bodyPr rtlCol="0" anchor="ctr" wrap="square"/>
+          <a:lstStyle/>
+          <a:p>
+            <a:pPr algn="ctr">
+              <a:lnSpc>
+                <a:spcPct val="103000"/>
+              </a:lnSpc>
+              <a:spcAft>
+                <a:spcPts val="0"/>
+              </a:spcAft>
+            </a:pPr>
+            <a:r>
+              <a:rPr sz="1200" b="1">
+                <a:solidFill>
+                  <a:srgbClr val="FFFFFF"/>
+                </a:solidFill>
+                <a:latin typeface="Calibri"/>
+              </a:rPr>
+              <a:t>CAUTION 2</a:t>
+            </a:r>
+          </a:p>
+        </p:txBody>
+      </p:sp>
+      <p:sp>
+        <p:nvSpPr>
+          <p:cNvPr id="7" name="Rounded Rectangle 6"/>
+          <p:cNvSpPr/>
+          <p:nvPr/>
+        </p:nvSpPr>
+        <p:spPr>
+          <a:xfrm>
+            <a:off x="548640" y="1965960"/>
+            <a:ext cx="5486400" cy="1417320"/>
+          </a:xfrm>
+          <a:prstGeom prst="roundRect">
+            <a:avLst/>
+          </a:prstGeom>
+          <a:solidFill>
+            <a:srgbClr val="FFFFFF"/>
+          </a:solidFill>
+          <a:ln w="22225">
+            <a:solidFill>
+              <a:srgbClr val="E08A1E"/>
+            </a:solidFill>
+          </a:ln>
+          <a:effectLst/>
+        </p:spPr>
+        <p:style>
+          <a:lnRef idx="1">
+            <a:schemeClr val="accent1"/>
+          </a:lnRef>
+          <a:fillRef idx="3">
+            <a:schemeClr val="accent1"/>
+          </a:fillRef>
+          <a:effectRef idx="2">
+            <a:schemeClr val="accent1"/>
+          </a:effectRef>
+          <a:fontRef idx="minor">
+            <a:schemeClr val="lt1"/>
+          </a:fontRef>
+        </p:style>
+        <p:txBody>
+          <a:bodyPr rtlCol="0" anchor="ctr"/>
+          <a:lstStyle/>
+          <a:p>
+            <a:pPr algn="ctr"/>
+          </a:p>
+        </p:txBody>
+      </p:sp>
+      <p:sp>
+        <p:nvSpPr>
+          <p:cNvPr id="8" name="Rectangle 7"/>
+          <p:cNvSpPr/>
+          <p:nvPr/>
+        </p:nvSpPr>
+        <p:spPr>
+          <a:xfrm>
+            <a:off x="548640" y="1965960"/>
+            <a:ext cx="118872" cy="1417320"/>
+          </a:xfrm>
+          <a:prstGeom prst="rect">
+            <a:avLst/>
+          </a:prstGeom>
+          <a:solidFill>
+            <a:srgbClr val="E08A1E"/>
+          </a:solidFill>
+          <a:ln>
+            <a:noFill/>
+          </a:ln>
+          <a:effectLst/>
+        </p:spPr>
+        <p:style>
+          <a:lnRef idx="1">
+            <a:schemeClr val="accent1"/>
+          </a:lnRef>
+          <a:fillRef idx="3">
+            <a:schemeClr val="accent1"/>
+          </a:fillRef>
+          <a:effectRef idx="2">
+            <a:schemeClr val="accent1"/>
+          </a:effectRef>
+          <a:fontRef idx="minor">
+            <a:schemeClr val="lt1"/>
+          </a:fontRef>
+        </p:style>
+        <p:txBody>
+          <a:bodyPr rtlCol="0" anchor="ctr"/>
+          <a:lstStyle/>
+          <a:p>
+            <a:pPr algn="ctr"/>
+          </a:p>
+        </p:txBody>
+      </p:sp>
+      <p:sp>
+        <p:nvSpPr>
+          <p:cNvPr id="9" name="TextBox 8"/>
+          <p:cNvSpPr txBox="1"/>
+          <p:nvPr/>
+        </p:nvSpPr>
+        <p:spPr>
+          <a:xfrm>
+            <a:off x="841248" y="2112264"/>
+            <a:ext cx="4983480" cy="1143000"/>
+          </a:xfrm>
+          <a:prstGeom prst="rect">
+            <a:avLst/>
+          </a:prstGeom>
+          <a:noFill/>
+        </p:spPr>
+        <p:txBody>
+          <a:bodyPr wrap="square" anchor="t">
+            <a:spAutoFit/>
+          </a:bodyPr>
+          <a:lstStyle/>
+          <a:p>
+            <a:pPr algn="l">
+              <a:lnSpc>
+                <a:spcPct val="103000"/>
+              </a:lnSpc>
+              <a:spcAft>
+                <a:spcPts val="500"/>
+              </a:spcAft>
+            </a:pPr>
+            <a:r>
+              <a:rPr sz="1500" b="1">
+                <a:solidFill>
+                  <a:srgbClr val="E08A1E"/>
+                </a:solidFill>
+                <a:latin typeface="Calibri"/>
+              </a:rPr>
+              <a:t>Coordination Token %</a:t>
+            </a:r>
+          </a:p>
+          <a:p>
+            <a:pPr algn="l">
+              <a:lnSpc>
+                <a:spcPct val="103000"/>
+              </a:lnSpc>
+              <a:spcAft>
+                <a:spcPts val="500"/>
+              </a:spcAft>
+            </a:pPr>
+            <a:r>
+              <a:rPr sz="1300" b="0">
+                <a:solidFill>
+                  <a:srgbClr val="1A1F2B"/>
+                </a:solidFill>
+                <a:latin typeface="Calibri"/>
+              </a:rPr>
+              <a:t>SRE reads it as COST. Engineer reads it as context bloat / prompt quality.</a:t>
+            </a:r>
+          </a:p>
+        </p:txBody>
+      </p:sp>
+      <p:sp>
+        <p:nvSpPr>
+          <p:cNvPr id="10" name="Rounded Rectangle 9"/>
+          <p:cNvSpPr/>
+          <p:nvPr/>
+        </p:nvSpPr>
+        <p:spPr>
+          <a:xfrm>
+            <a:off x="548640" y="3566160"/>
+            <a:ext cx="5486400" cy="1417320"/>
+          </a:xfrm>
+          <a:prstGeom prst="roundRect">
+            <a:avLst/>
+          </a:prstGeom>
+          <a:solidFill>
+            <a:srgbClr val="FFFFFF"/>
+          </a:solidFill>
+          <a:ln w="22225">
+            <a:solidFill>
+              <a:srgbClr val="2D6CDF"/>
+            </a:solidFill>
+          </a:ln>
+          <a:effectLst/>
+        </p:spPr>
+        <p:style>
+          <a:lnRef idx="1">
+            <a:schemeClr val="accent1"/>
+          </a:lnRef>
+          <a:fillRef idx="3">
+            <a:schemeClr val="accent1"/>
+          </a:fillRef>
+          <a:effectRef idx="2">
+            <a:schemeClr val="accent1"/>
+          </a:effectRef>
+          <a:fontRef idx="minor">
+            <a:schemeClr val="lt1"/>
+          </a:fontRef>
+        </p:style>
+        <p:txBody>
+          <a:bodyPr rtlCol="0" anchor="ctr"/>
+          <a:lstStyle/>
+          <a:p>
+            <a:pPr algn="ctr"/>
+          </a:p>
+        </p:txBody>
+      </p:sp>
+      <p:sp>
+        <p:nvSpPr>
+          <p:cNvPr id="11" name="Rectangle 10"/>
+          <p:cNvSpPr/>
+          <p:nvPr/>
+        </p:nvSpPr>
+        <p:spPr>
+          <a:xfrm>
+            <a:off x="548640" y="3566160"/>
+            <a:ext cx="118872" cy="1417320"/>
+          </a:xfrm>
+          <a:prstGeom prst="rect">
+            <a:avLst/>
+          </a:prstGeom>
+          <a:solidFill>
+            <a:srgbClr val="2D6CDF"/>
+          </a:solidFill>
+          <a:ln>
+            <a:noFill/>
+          </a:ln>
+          <a:effectLst/>
+        </p:spPr>
+        <p:style>
+          <a:lnRef idx="1">
+            <a:schemeClr val="accent1"/>
+          </a:lnRef>
+          <a:fillRef idx="3">
+            <a:schemeClr val="accent1"/>
+          </a:fillRef>
+          <a:effectRef idx="2">
+            <a:schemeClr val="accent1"/>
+          </a:effectRef>
+          <a:fontRef idx="minor">
+            <a:schemeClr val="lt1"/>
+          </a:fontRef>
+        </p:style>
+        <p:txBody>
+          <a:bodyPr rtlCol="0" anchor="ctr"/>
+          <a:lstStyle/>
+          <a:p>
+            <a:pPr algn="ctr"/>
+          </a:p>
+        </p:txBody>
+      </p:sp>
+      <p:sp>
+        <p:nvSpPr>
+          <p:cNvPr id="12" name="TextBox 11"/>
+          <p:cNvSpPr txBox="1"/>
+          <p:nvPr/>
+        </p:nvSpPr>
+        <p:spPr>
+          <a:xfrm>
+            <a:off x="841248" y="3712464"/>
+            <a:ext cx="4983480" cy="1143000"/>
+          </a:xfrm>
+          <a:prstGeom prst="rect">
+            <a:avLst/>
+          </a:prstGeom>
+          <a:noFill/>
+        </p:spPr>
+        <p:txBody>
+          <a:bodyPr wrap="square" anchor="t">
+            <a:spAutoFit/>
+          </a:bodyPr>
+          <a:lstStyle/>
+          <a:p>
+            <a:pPr algn="l">
+              <a:lnSpc>
+                <a:spcPct val="103000"/>
+              </a:lnSpc>
+              <a:spcAft>
+                <a:spcPts val="500"/>
+              </a:spcAft>
+            </a:pPr>
+            <a:r>
+              <a:rPr sz="1500" b="1">
+                <a:solidFill>
+                  <a:srgbClr val="2D6CDF"/>
+                </a:solidFill>
+                <a:latin typeface="Calibri"/>
+              </a:rPr>
+              <a:t>Latency</a:t>
+            </a:r>
+          </a:p>
+          <a:p>
+            <a:pPr algn="l">
+              <a:lnSpc>
+                <a:spcPct val="103000"/>
+              </a:lnSpc>
+              <a:spcAft>
+                <a:spcPts val="500"/>
+              </a:spcAft>
+            </a:pPr>
+            <a:r>
+              <a:rPr sz="1300" b="0">
+                <a:solidFill>
+                  <a:srgbClr val="1A1F2B"/>
+                </a:solidFill>
+                <a:latin typeface="Calibri"/>
+              </a:rPr>
+              <a:t>Ops reads it as an SLA. PM reads it as user-perceived responsiveness.</a:t>
+            </a:r>
+          </a:p>
+        </p:txBody>
+      </p:sp>
+      <p:sp>
+        <p:nvSpPr>
+          <p:cNvPr id="13" name="Rounded Rectangle 12"/>
+          <p:cNvSpPr/>
+          <p:nvPr/>
+        </p:nvSpPr>
+        <p:spPr>
+          <a:xfrm>
+            <a:off x="6309360" y="1965960"/>
+            <a:ext cx="5349240" cy="3931920"/>
+          </a:xfrm>
+          <a:prstGeom prst="roundRect">
+            <a:avLst/>
+          </a:prstGeom>
+          <a:solidFill>
+            <a:srgbClr val="F2F5FA"/>
+          </a:solidFill>
+          <a:ln w="25400">
+            <a:solidFill>
+              <a:srgbClr val="E08A1E"/>
+            </a:solidFill>
+          </a:ln>
+          <a:effectLst/>
+        </p:spPr>
+        <p:style>
+          <a:lnRef idx="1">
+            <a:schemeClr val="accent1"/>
+          </a:lnRef>
+          <a:fillRef idx="3">
+            <a:schemeClr val="accent1"/>
+          </a:fillRef>
+          <a:effectRef idx="2">
+            <a:schemeClr val="accent1"/>
+          </a:effectRef>
+          <a:fontRef idx="minor">
+            <a:schemeClr val="lt1"/>
+          </a:fontRef>
+        </p:style>
+        <p:txBody>
+          <a:bodyPr rtlCol="0" anchor="t" wrap="square" lIns="292608" rIns="256032" tIns="256032"/>
+          <a:lstStyle/>
+          <a:p>
+            <a:pPr algn="l">
+              <a:lnSpc>
+                <a:spcPct val="103000"/>
+              </a:lnSpc>
+              <a:spcAft>
+                <a:spcPts val="900"/>
+              </a:spcAft>
+            </a:pPr>
+            <a:r>
+              <a:rPr sz="1600" b="1">
+                <a:solidFill>
+                  <a:srgbClr val="1A1F2B"/>
+                </a:solidFill>
+                <a:latin typeface="Calibri"/>
+              </a:rPr>
+              <a:t>One number ≠ one meaning.</a:t>
+            </a:r>
+          </a:p>
+          <a:p>
+            <a:pPr algn="l">
+              <a:lnSpc>
+                <a:spcPct val="103000"/>
+              </a:lnSpc>
+              <a:spcAft>
+                <a:spcPts val="900"/>
+              </a:spcAft>
+            </a:pPr>
+            <a:r>
+              <a:rPr sz="1400" b="0">
+                <a:solidFill>
+                  <a:srgbClr val="5B6470"/>
+                </a:solidFill>
+                <a:latin typeface="Calibri"/>
+              </a:rPr>
+              <a:t>The metric is shared; the interpretation and the threshold are not.</a:t>
+            </a:r>
+          </a:p>
+          <a:p>
+            <a:pPr algn="l">
+              <a:lnSpc>
+                <a:spcPct val="103000"/>
+              </a:lnSpc>
+              <a:spcAft>
+                <a:spcPts val="900"/>
+              </a:spcAft>
+            </a:pPr>
+            <a:r>
+              <a:rPr sz="600" b="0">
+                <a:solidFill>
+                  <a:srgbClr val="5B6470"/>
+                </a:solidFill>
+                <a:latin typeface="Calibri"/>
+              </a:rPr>
+              <a:t/>
+            </a:r>
+          </a:p>
+          <a:p>
+            <a:pPr algn="l">
+              <a:lnSpc>
+                <a:spcPct val="103000"/>
+              </a:lnSpc>
+              <a:spcAft>
+                <a:spcPts val="900"/>
+              </a:spcAft>
+            </a:pPr>
+            <a:r>
+              <a:rPr sz="1500" b="1">
+                <a:solidFill>
+                  <a:srgbClr val="E08A1E"/>
+                </a:solidFill>
+                <a:latin typeface="Calibri"/>
+              </a:rPr>
+              <a:t>A persona view = metric + interpretation + threshold</a:t>
+            </a:r>
+          </a:p>
+          <a:p>
+            <a:pPr algn="l">
+              <a:lnSpc>
+                <a:spcPct val="103000"/>
+              </a:lnSpc>
+              <a:spcAft>
+                <a:spcPts val="900"/>
+              </a:spcAft>
+            </a:pPr>
+            <a:r>
+              <a:rPr sz="1350" b="0">
+                <a:solidFill>
+                  <a:srgbClr val="1A1F2B"/>
+                </a:solidFill>
+                <a:latin typeface="Calibri"/>
+              </a:rPr>
+              <a:t>…not just a filtered column list. Don’t assume a shared definition just because you share a column header.</a:t>
+            </a:r>
+          </a:p>
+        </p:txBody>
+      </p:sp>
+      <p:sp>
+        <p:nvSpPr>
+          <p:cNvPr id="14" name="Rounded Rectangle 13"/>
+          <p:cNvSpPr/>
+          <p:nvPr/>
+        </p:nvSpPr>
+        <p:spPr>
+          <a:xfrm>
+            <a:off x="6601968" y="2148840"/>
+            <a:ext cx="3108960" cy="384048"/>
+          </a:xfrm>
+          <a:prstGeom prst="roundRect">
+            <a:avLst/>
+          </a:prstGeom>
+          <a:solidFill>
+            <a:srgbClr val="E08A1E"/>
+          </a:solidFill>
+          <a:ln>
+            <a:noFill/>
+          </a:ln>
+          <a:effectLst/>
+        </p:spPr>
+        <p:style>
+          <a:lnRef idx="1">
+            <a:schemeClr val="accent1"/>
+          </a:lnRef>
+          <a:fillRef idx="3">
+            <a:schemeClr val="accent1"/>
+          </a:fillRef>
+          <a:effectRef idx="2">
+            <a:schemeClr val="accent1"/>
+          </a:effectRef>
+          <a:fontRef idx="minor">
+            <a:schemeClr val="lt1"/>
+          </a:fontRef>
+        </p:style>
+        <p:txBody>
+          <a:bodyPr rtlCol="0" anchor="ctr" wrap="square"/>
+          <a:lstStyle/>
+          <a:p>
+            <a:pPr algn="ctr">
+              <a:lnSpc>
+                <a:spcPct val="103000"/>
+              </a:lnSpc>
+              <a:spcAft>
+                <a:spcPts val="0"/>
+              </a:spcAft>
+            </a:pPr>
+            <a:r>
+              <a:rPr sz="1200" b="1">
+                <a:solidFill>
+                  <a:srgbClr val="FFFFFF"/>
+                </a:solidFill>
+                <a:latin typeface="Calibri"/>
+              </a:rPr>
+              <a:t>THE TRAP</a:t>
+            </a:r>
+          </a:p>
+        </p:txBody>
+      </p:sp>
+    </p:spTree>
+  </p:cSld>
+  <p:clrMapOvr>
+    <a:masterClrMapping/>
+  </p:clrMapOvr>
+</p:sld>
+</file>
+
+<file path=ppt/slides/slide8.xml><?xml version="1.0" encoding="utf-8"?>
+<p:sld xmlns:a="http://schemas.openxmlformats.org/drawingml/2006/main" xmlns:p="http://schemas.openxmlformats.org/presentationml/2006/main" xmlns:r="http://schemas.openxmlformats.org/officeDocument/2006/relationships">
+  <p:cSld>
+    <p:spTree>
+      <p:nvGrpSpPr>
+        <p:cNvPr id="1" name=""/>
+        <p:cNvGrpSpPr/>
+        <p:nvPr/>
+      </p:nvGrpSpPr>
+      <p:grpSpPr/>
+      <p:sp>
+        <p:nvSpPr>
+          <p:cNvPr id="2" name="Rectangle 1"/>
+          <p:cNvSpPr/>
+          <p:nvPr/>
+        </p:nvSpPr>
+        <p:spPr>
+          <a:xfrm>
+            <a:off x="0" y="0"/>
+            <a:ext cx="12191695" cy="6858000"/>
+          </a:xfrm>
+          <a:prstGeom prst="rect">
+            <a:avLst/>
+          </a:prstGeom>
+          <a:solidFill>
+            <a:srgbClr val="FFFFFF"/>
+          </a:solidFill>
+          <a:ln>
+            <a:noFill/>
+          </a:ln>
+          <a:effectLst/>
+        </p:spPr>
+        <p:style>
+          <a:lnRef idx="1">
+            <a:schemeClr val="accent1"/>
+          </a:lnRef>
+          <a:fillRef idx="3">
+            <a:schemeClr val="accent1"/>
+          </a:fillRef>
+          <a:effectRef idx="2">
+            <a:schemeClr val="accent1"/>
+          </a:effectRef>
+          <a:fontRef idx="minor">
+            <a:schemeClr val="lt1"/>
+          </a:fontRef>
+        </p:style>
+        <p:txBody>
+          <a:bodyPr rtlCol="0" anchor="ctr"/>
+          <a:lstStyle/>
+          <a:p>
+            <a:pPr algn="ctr"/>
+          </a:p>
+        </p:txBody>
+      </p:sp>
+      <p:sp>
+        <p:nvSpPr>
+          <p:cNvPr id="3" name="Rectangle 2"/>
+          <p:cNvSpPr/>
+          <p:nvPr/>
+        </p:nvSpPr>
+        <p:spPr>
+          <a:xfrm>
+            <a:off x="0" y="0"/>
+            <a:ext cx="12191695" cy="1097280"/>
+          </a:xfrm>
+          <a:prstGeom prst="rect">
+            <a:avLst/>
+          </a:prstGeom>
+          <a:solidFill>
+            <a:srgbClr val="0F2A4A"/>
+          </a:solidFill>
+          <a:ln>
+            <a:noFill/>
+          </a:ln>
+          <a:effectLst/>
+        </p:spPr>
+        <p:style>
+          <a:lnRef idx="1">
+            <a:schemeClr val="accent1"/>
+          </a:lnRef>
+          <a:fillRef idx="3">
+            <a:schemeClr val="accent1"/>
+          </a:fillRef>
+          <a:effectRef idx="2">
+            <a:schemeClr val="accent1"/>
+          </a:effectRef>
+          <a:fontRef idx="minor">
+            <a:schemeClr val="lt1"/>
+          </a:fontRef>
+        </p:style>
+        <p:txBody>
+          <a:bodyPr rtlCol="0" anchor="ctr"/>
+          <a:lstStyle/>
+          <a:p>
+            <a:pPr algn="ctr"/>
+          </a:p>
+        </p:txBody>
+      </p:sp>
+      <p:sp>
+        <p:nvSpPr>
+          <p:cNvPr id="4" name="Rectangle 3"/>
+          <p:cNvSpPr/>
+          <p:nvPr/>
+        </p:nvSpPr>
+        <p:spPr>
+          <a:xfrm>
+            <a:off x="0" y="1097280"/>
+            <a:ext cx="12191695" cy="54864"/>
+          </a:xfrm>
+          <a:prstGeom prst="rect">
+            <a:avLst/>
+          </a:prstGeom>
+          <a:solidFill>
+            <a:srgbClr val="2D6CDF"/>
+          </a:solidFill>
+          <a:ln>
+            <a:noFill/>
+          </a:ln>
+          <a:effectLst/>
+        </p:spPr>
+        <p:style>
+          <a:lnRef idx="1">
+            <a:schemeClr val="accent1"/>
+          </a:lnRef>
+          <a:fillRef idx="3">
+            <a:schemeClr val="accent1"/>
+          </a:fillRef>
+          <a:effectRef idx="2">
+            <a:schemeClr val="accent1"/>
+          </a:effectRef>
+          <a:fontRef idx="minor">
+            <a:schemeClr val="lt1"/>
+          </a:fontRef>
+        </p:style>
+        <p:txBody>
+          <a:bodyPr rtlCol="0" anchor="ctr"/>
+          <a:lstStyle/>
+          <a:p>
+            <a:pPr algn="ctr"/>
+          </a:p>
+        </p:txBody>
+      </p:sp>
+      <p:sp>
+        <p:nvSpPr>
+          <p:cNvPr id="5" name="TextBox 4"/>
+          <p:cNvSpPr txBox="1"/>
+          <p:nvPr/>
+        </p:nvSpPr>
+        <p:spPr>
+          <a:xfrm>
+            <a:off x="548640" y="128016"/>
+            <a:ext cx="11064240" cy="914400"/>
+          </a:xfrm>
+          <a:prstGeom prst="rect">
+            <a:avLst/>
+          </a:prstGeom>
+          <a:noFill/>
+        </p:spPr>
+        <p:txBody>
+          <a:bodyPr wrap="square" anchor="t">
+            <a:spAutoFit/>
+          </a:bodyPr>
+          <a:lstStyle/>
+          <a:p>
+            <a:pPr algn="l">
+              <a:lnSpc>
+                <a:spcPct val="103000"/>
+              </a:lnSpc>
+              <a:spcAft>
+                <a:spcPts val="200"/>
+              </a:spcAft>
+            </a:pPr>
+            <a:r>
+              <a:rPr sz="1200" b="1">
+                <a:solidFill>
+                  <a:srgbClr val="BFD0EA"/>
+                </a:solidFill>
+                <a:latin typeface="Calibri"/>
+              </a:rPr>
+              <a:t>CAUTION 3</a:t>
+            </a:r>
+          </a:p>
+          <a:p>
+            <a:pPr algn="l">
+              <a:lnSpc>
+                <a:spcPct val="103000"/>
+              </a:lnSpc>
+              <a:spcAft>
+                <a:spcPts val="200"/>
+              </a:spcAft>
+            </a:pPr>
+            <a:r>
+              <a:rPr sz="2700" b="1">
+                <a:solidFill>
+                  <a:srgbClr val="FFFFFF"/>
+                </a:solidFill>
+                <a:latin typeface="Calibri"/>
+              </a:rPr>
+              <a:t>Persona is a different axis from lifecycle stage</a:t>
+            </a:r>
+          </a:p>
+        </p:txBody>
+      </p:sp>
+      <p:sp>
+        <p:nvSpPr>
+          <p:cNvPr id="6" name="Rounded Rectangle 5"/>
+          <p:cNvSpPr/>
+          <p:nvPr/>
+        </p:nvSpPr>
+        <p:spPr>
+          <a:xfrm>
+            <a:off x="548640" y="1325880"/>
+            <a:ext cx="2011680" cy="384048"/>
+          </a:xfrm>
+          <a:prstGeom prst="roundRect">
+            <a:avLst/>
+          </a:prstGeom>
+          <a:solidFill>
+            <a:srgbClr val="6B4EC4"/>
+          </a:solidFill>
+          <a:ln>
+            <a:noFill/>
+          </a:ln>
+          <a:effectLst/>
+        </p:spPr>
+        <p:style>
+          <a:lnRef idx="1">
+            <a:schemeClr val="accent1"/>
+          </a:lnRef>
+          <a:fillRef idx="3">
+            <a:schemeClr val="accent1"/>
+          </a:fillRef>
+          <a:effectRef idx="2">
+            <a:schemeClr val="accent1"/>
+          </a:effectRef>
+          <a:fontRef idx="minor">
+            <a:schemeClr val="lt1"/>
+          </a:fontRef>
+        </p:style>
+        <p:txBody>
+          <a:bodyPr rtlCol="0" anchor="ctr" wrap="square"/>
+          <a:lstStyle/>
+          <a:p>
+            <a:pPr algn="ctr">
+              <a:lnSpc>
+                <a:spcPct val="103000"/>
+              </a:lnSpc>
+              <a:spcAft>
+                <a:spcPts val="0"/>
+              </a:spcAft>
+            </a:pPr>
+            <a:r>
+              <a:rPr sz="1200" b="1">
+                <a:solidFill>
+                  <a:srgbClr val="FFFFFF"/>
+                </a:solidFill>
+                <a:latin typeface="Calibri"/>
+              </a:rPr>
+              <a:t>CAUTION 3</a:t>
+            </a:r>
+          </a:p>
+        </p:txBody>
+      </p:sp>
+      <p:sp>
+        <p:nvSpPr>
+          <p:cNvPr id="7" name="Rounded Rectangle 6"/>
+          <p:cNvSpPr/>
+          <p:nvPr/>
+        </p:nvSpPr>
+        <p:spPr>
+          <a:xfrm>
+            <a:off x="548640" y="1965960"/>
+            <a:ext cx="5486400" cy="1417320"/>
+          </a:xfrm>
+          <a:prstGeom prst="roundRect">
+            <a:avLst/>
+          </a:prstGeom>
+          <a:solidFill>
+            <a:srgbClr val="FFFFFF"/>
+          </a:solidFill>
+          <a:ln w="22225">
+            <a:solidFill>
+              <a:srgbClr val="6B4EC4"/>
+            </a:solidFill>
+          </a:ln>
+          <a:effectLst/>
+        </p:spPr>
+        <p:style>
+          <a:lnRef idx="1">
+            <a:schemeClr val="accent1"/>
+          </a:lnRef>
+          <a:fillRef idx="3">
+            <a:schemeClr val="accent1"/>
+          </a:fillRef>
+          <a:effectRef idx="2">
+            <a:schemeClr val="accent1"/>
+          </a:effectRef>
+          <a:fontRef idx="minor">
+            <a:schemeClr val="lt1"/>
+          </a:fontRef>
+        </p:style>
+        <p:txBody>
+          <a:bodyPr rtlCol="0" anchor="ctr"/>
+          <a:lstStyle/>
+          <a:p>
+            <a:pPr algn="ctr"/>
+          </a:p>
+        </p:txBody>
+      </p:sp>
+      <p:sp>
+        <p:nvSpPr>
+          <p:cNvPr id="8" name="Rectangle 7"/>
+          <p:cNvSpPr/>
+          <p:nvPr/>
+        </p:nvSpPr>
+        <p:spPr>
+          <a:xfrm>
+            <a:off x="548640" y="1965960"/>
+            <a:ext cx="118872" cy="1417320"/>
+          </a:xfrm>
+          <a:prstGeom prst="rect">
+            <a:avLst/>
+          </a:prstGeom>
+          <a:solidFill>
+            <a:srgbClr val="6B4EC4"/>
+          </a:solidFill>
+          <a:ln>
+            <a:noFill/>
+          </a:ln>
+          <a:effectLst/>
+        </p:spPr>
+        <p:style>
+          <a:lnRef idx="1">
+            <a:schemeClr val="accent1"/>
+          </a:lnRef>
+          <a:fillRef idx="3">
+            <a:schemeClr val="accent1"/>
+          </a:fillRef>
+          <a:effectRef idx="2">
+            <a:schemeClr val="accent1"/>
+          </a:effectRef>
+          <a:fontRef idx="minor">
+            <a:schemeClr val="lt1"/>
+          </a:fontRef>
+        </p:style>
+        <p:txBody>
+          <a:bodyPr rtlCol="0" anchor="ctr"/>
+          <a:lstStyle/>
+          <a:p>
+            <a:pPr algn="ctr"/>
+          </a:p>
+        </p:txBody>
+      </p:sp>
+      <p:sp>
+        <p:nvSpPr>
+          <p:cNvPr id="9" name="TextBox 8"/>
+          <p:cNvSpPr txBox="1"/>
+          <p:nvPr/>
+        </p:nvSpPr>
+        <p:spPr>
+          <a:xfrm>
+            <a:off x="841248" y="2112264"/>
+            <a:ext cx="4983480" cy="1143000"/>
+          </a:xfrm>
+          <a:prstGeom prst="rect">
+            <a:avLst/>
+          </a:prstGeom>
+          <a:noFill/>
+        </p:spPr>
+        <p:txBody>
+          <a:bodyPr wrap="square" anchor="t">
+            <a:spAutoFit/>
+          </a:bodyPr>
+          <a:lstStyle/>
+          <a:p>
+            <a:pPr algn="l">
+              <a:lnSpc>
+                <a:spcPct val="103000"/>
+              </a:lnSpc>
+              <a:spcAft>
+                <a:spcPts val="500"/>
+              </a:spcAft>
+            </a:pPr>
+            <a:r>
+              <a:rPr sz="1500" b="1">
+                <a:solidFill>
+                  <a:srgbClr val="6B4EC4"/>
+                </a:solidFill>
+                <a:latin typeface="Calibri"/>
+              </a:rPr>
+              <a:t>WHO  (persona)</a:t>
+            </a:r>
+          </a:p>
+          <a:p>
+            <a:pPr algn="l">
+              <a:lnSpc>
+                <a:spcPct val="103000"/>
+              </a:lnSpc>
+              <a:spcAft>
+                <a:spcPts val="500"/>
+              </a:spcAft>
+            </a:pPr>
+            <a:r>
+              <a:rPr sz="1300" b="0">
+                <a:solidFill>
+                  <a:srgbClr val="1A1F2B"/>
+                </a:solidFill>
+                <a:latin typeface="Calibri"/>
+              </a:rPr>
+              <a:t>PM / Domain • App Engineer • Platform • SRE</a:t>
+            </a:r>
+          </a:p>
+        </p:txBody>
+      </p:sp>
+      <p:sp>
+        <p:nvSpPr>
+          <p:cNvPr id="10" name="Rounded Rectangle 9"/>
+          <p:cNvSpPr/>
+          <p:nvPr/>
+        </p:nvSpPr>
+        <p:spPr>
+          <a:xfrm>
+            <a:off x="548640" y="3566160"/>
+            <a:ext cx="5486400" cy="1417320"/>
+          </a:xfrm>
+          <a:prstGeom prst="roundRect">
+            <a:avLst/>
+          </a:prstGeom>
+          <a:solidFill>
+            <a:srgbClr val="FFFFFF"/>
+          </a:solidFill>
+          <a:ln w="22225">
+            <a:solidFill>
+              <a:srgbClr val="2D6CDF"/>
+            </a:solidFill>
+          </a:ln>
+          <a:effectLst/>
+        </p:spPr>
+        <p:style>
+          <a:lnRef idx="1">
+            <a:schemeClr val="accent1"/>
+          </a:lnRef>
+          <a:fillRef idx="3">
+            <a:schemeClr val="accent1"/>
+          </a:fillRef>
+          <a:effectRef idx="2">
+            <a:schemeClr val="accent1"/>
+          </a:effectRef>
+          <a:fontRef idx="minor">
+            <a:schemeClr val="lt1"/>
+          </a:fontRef>
+        </p:style>
+        <p:txBody>
+          <a:bodyPr rtlCol="0" anchor="ctr"/>
+          <a:lstStyle/>
+          <a:p>
+            <a:pPr algn="ctr"/>
+          </a:p>
+        </p:txBody>
+      </p:sp>
+      <p:sp>
+        <p:nvSpPr>
+          <p:cNvPr id="11" name="Rectangle 10"/>
+          <p:cNvSpPr/>
+          <p:nvPr/>
+        </p:nvSpPr>
+        <p:spPr>
+          <a:xfrm>
+            <a:off x="548640" y="3566160"/>
+            <a:ext cx="118872" cy="1417320"/>
+          </a:xfrm>
+          <a:prstGeom prst="rect">
+            <a:avLst/>
+          </a:prstGeom>
+          <a:solidFill>
+            <a:srgbClr val="2D6CDF"/>
+          </a:solidFill>
+          <a:ln>
+            <a:noFill/>
+          </a:ln>
+          <a:effectLst/>
+        </p:spPr>
+        <p:style>
+          <a:lnRef idx="1">
+            <a:schemeClr val="accent1"/>
+          </a:lnRef>
+          <a:fillRef idx="3">
+            <a:schemeClr val="accent1"/>
+          </a:fillRef>
+          <a:effectRef idx="2">
+            <a:schemeClr val="accent1"/>
+          </a:effectRef>
+          <a:fontRef idx="minor">
+            <a:schemeClr val="lt1"/>
+          </a:fontRef>
+        </p:style>
+        <p:txBody>
+          <a:bodyPr rtlCol="0" anchor="ctr"/>
+          <a:lstStyle/>
+          <a:p>
+            <a:pPr algn="ctr"/>
+          </a:p>
+        </p:txBody>
+      </p:sp>
+      <p:sp>
+        <p:nvSpPr>
+          <p:cNvPr id="12" name="TextBox 11"/>
+          <p:cNvSpPr txBox="1"/>
+          <p:nvPr/>
+        </p:nvSpPr>
+        <p:spPr>
+          <a:xfrm>
+            <a:off x="841248" y="3712464"/>
+            <a:ext cx="4983480" cy="1143000"/>
+          </a:xfrm>
+          <a:prstGeom prst="rect">
+            <a:avLst/>
+          </a:prstGeom>
+          <a:noFill/>
+        </p:spPr>
+        <p:txBody>
+          <a:bodyPr wrap="square" anchor="t">
+            <a:spAutoFit/>
+          </a:bodyPr>
+          <a:lstStyle/>
+          <a:p>
+            <a:pPr algn="l">
+              <a:lnSpc>
+                <a:spcPct val="103000"/>
+              </a:lnSpc>
+              <a:spcAft>
+                <a:spcPts val="500"/>
+              </a:spcAft>
+            </a:pPr>
+            <a:r>
+              <a:rPr sz="1500" b="1">
+                <a:solidFill>
+                  <a:srgbClr val="2D6CDF"/>
+                </a:solidFill>
+                <a:latin typeface="Calibri"/>
+              </a:rPr>
+              <a:t>WHEN  (stage)</a:t>
+            </a:r>
+          </a:p>
+          <a:p>
+            <a:pPr algn="l">
+              <a:lnSpc>
+                <a:spcPct val="103000"/>
+              </a:lnSpc>
+              <a:spcAft>
+                <a:spcPts val="500"/>
+              </a:spcAft>
+            </a:pPr>
+            <a:r>
+              <a:rPr sz="1300" b="0">
+                <a:solidFill>
+                  <a:srgbClr val="1A1F2B"/>
+                </a:solidFill>
+                <a:latin typeface="Calibri"/>
+              </a:rPr>
+              <a:t>Design • Code • Deploy • Operate</a:t>
+            </a:r>
+          </a:p>
+        </p:txBody>
+      </p:sp>
+      <p:sp>
+        <p:nvSpPr>
+          <p:cNvPr id="13" name="Rounded Rectangle 12"/>
+          <p:cNvSpPr/>
+          <p:nvPr/>
+        </p:nvSpPr>
+        <p:spPr>
+          <a:xfrm>
+            <a:off x="6309360" y="1965960"/>
+            <a:ext cx="5349240" cy="3931920"/>
+          </a:xfrm>
+          <a:prstGeom prst="roundRect">
+            <a:avLst/>
+          </a:prstGeom>
+          <a:solidFill>
+            <a:srgbClr val="F2F5FA"/>
+          </a:solidFill>
+          <a:ln w="25400">
+            <a:solidFill>
+              <a:srgbClr val="6B4EC4"/>
+            </a:solidFill>
+          </a:ln>
+          <a:effectLst/>
+        </p:spPr>
+        <p:style>
+          <a:lnRef idx="1">
+            <a:schemeClr val="accent1"/>
+          </a:lnRef>
+          <a:fillRef idx="3">
+            <a:schemeClr val="accent1"/>
+          </a:fillRef>
+          <a:effectRef idx="2">
+            <a:schemeClr val="accent1"/>
+          </a:effectRef>
+          <a:fontRef idx="minor">
+            <a:schemeClr val="lt1"/>
+          </a:fontRef>
+        </p:style>
+        <p:txBody>
+          <a:bodyPr rtlCol="0" anchor="t" wrap="square" lIns="292608" rIns="256032" tIns="256032"/>
+          <a:lstStyle/>
+          <a:p>
+            <a:pPr algn="l">
+              <a:lnSpc>
+                <a:spcPct val="103000"/>
+              </a:lnSpc>
+              <a:spcAft>
+                <a:spcPts val="900"/>
+              </a:spcAft>
+            </a:pPr>
+            <a:r>
+              <a:rPr sz="1600" b="1">
+                <a:solidFill>
+                  <a:srgbClr val="1A1F2B"/>
+                </a:solidFill>
+                <a:latin typeface="Calibri"/>
+              </a:rPr>
+              <a:t>They correlate — but they are not the same axis.</a:t>
+            </a:r>
+          </a:p>
+          <a:p>
+            <a:pPr algn="l">
+              <a:lnSpc>
+                <a:spcPct val="103000"/>
+              </a:lnSpc>
+              <a:spcAft>
+                <a:spcPts val="900"/>
+              </a:spcAft>
+            </a:pPr>
+            <a:r>
+              <a:rPr sz="1400" b="0">
+                <a:solidFill>
+                  <a:srgbClr val="5B6470"/>
+                </a:solidFill>
+                <a:latin typeface="Calibri"/>
+              </a:rPr>
+              <a:t>Groundedness is not “design-only.” It is a design-time gate AND a production canary (e.g. drift after a model swap).</a:t>
+            </a:r>
+          </a:p>
+          <a:p>
+            <a:pPr algn="l">
+              <a:lnSpc>
+                <a:spcPct val="103000"/>
+              </a:lnSpc>
+              <a:spcAft>
+                <a:spcPts val="900"/>
+              </a:spcAft>
+            </a:pPr>
+            <a:r>
+              <a:rPr sz="600" b="0">
+                <a:solidFill>
+                  <a:srgbClr val="5B6470"/>
+                </a:solidFill>
+                <a:latin typeface="Calibri"/>
+              </a:rPr>
+              <a:t/>
+            </a:r>
+          </a:p>
+          <a:p>
+            <a:pPr algn="l">
+              <a:lnSpc>
+                <a:spcPct val="103000"/>
+              </a:lnSpc>
+              <a:spcAft>
+                <a:spcPts val="900"/>
+              </a:spcAft>
+            </a:pPr>
+            <a:r>
+              <a:rPr sz="1500" b="1">
+                <a:solidFill>
+                  <a:srgbClr val="6B4EC4"/>
+                </a:solidFill>
+                <a:latin typeface="Calibri"/>
+              </a:rPr>
+              <a:t>Keep two axes: who + when.</a:t>
+            </a:r>
+          </a:p>
+          <a:p>
+            <a:pPr algn="l">
+              <a:lnSpc>
+                <a:spcPct val="103000"/>
+              </a:lnSpc>
+              <a:spcAft>
+                <a:spcPts val="900"/>
+              </a:spcAft>
+            </a:pPr>
+            <a:r>
+              <a:rPr sz="1350" b="0">
+                <a:solidFill>
+                  <a:srgbClr val="1A1F2B"/>
+                </a:solidFill>
+                <a:latin typeface="Calibri"/>
+              </a:rPr>
+              <a:t>The same metric recurs at multiple stages with different urgency. Collapsing the axes makes coverage look complete when it isn’t.</a:t>
+            </a:r>
+          </a:p>
+        </p:txBody>
+      </p:sp>
+      <p:sp>
+        <p:nvSpPr>
+          <p:cNvPr id="14" name="Rounded Rectangle 13"/>
+          <p:cNvSpPr/>
+          <p:nvPr/>
+        </p:nvSpPr>
+        <p:spPr>
+          <a:xfrm>
+            <a:off x="6601968" y="2148840"/>
+            <a:ext cx="3108960" cy="384048"/>
+          </a:xfrm>
+          <a:prstGeom prst="roundRect">
+            <a:avLst/>
+          </a:prstGeom>
+          <a:solidFill>
+            <a:srgbClr val="6B4EC4"/>
+          </a:solidFill>
+          <a:ln>
+            <a:noFill/>
+          </a:ln>
+          <a:effectLst/>
+        </p:spPr>
+        <p:style>
+          <a:lnRef idx="1">
+            <a:schemeClr val="accent1"/>
+          </a:lnRef>
+          <a:fillRef idx="3">
+            <a:schemeClr val="accent1"/>
+          </a:fillRef>
+          <a:effectRef idx="2">
+            <a:schemeClr val="accent1"/>
+          </a:effectRef>
+          <a:fontRef idx="minor">
+            <a:schemeClr val="lt1"/>
+          </a:fontRef>
+        </p:style>
+        <p:txBody>
+          <a:bodyPr rtlCol="0" anchor="ctr" wrap="square"/>
+          <a:lstStyle/>
+          <a:p>
+            <a:pPr algn="ctr">
+              <a:lnSpc>
+                <a:spcPct val="103000"/>
+              </a:lnSpc>
+              <a:spcAft>
+                <a:spcPts val="0"/>
+              </a:spcAft>
+            </a:pPr>
+            <a:r>
+              <a:rPr sz="1200" b="1">
+                <a:solidFill>
+                  <a:srgbClr val="FFFFFF"/>
+                </a:solidFill>
+                <a:latin typeface="Calibri"/>
+              </a:rPr>
+              <a:t>THE TRAP</a:t>
+            </a:r>
+          </a:p>
+        </p:txBody>
+      </p:sp>
+    </p:spTree>
+  </p:cSld>
+  <p:clrMapOvr>
+    <a:masterClrMapping/>
+  </p:clrMapOvr>
+</p:sld>
+</file>
+
+<file path=ppt/slides/slide9.xml><?xml version="1.0" encoding="utf-8"?>
 <p:sld xmlns:a="http://schemas.openxmlformats.org/drawingml/2006/main" xmlns:p="http://schemas.openxmlformats.org/presentationml/2006/main" xmlns:r="http://schemas.openxmlformats.org/officeDocument/2006/relationships">
   <p:cSld>
     <p:spTree>

</xml_diff>